<commit_message>
OK Creative: interactieve pagina en correctie op de verklaring van periode 1
- interactieve pagina in dezelfde huisstijl: vier klikbare bellijsten, de
  pijplijn uit de export, en een rekenmachine met twee knoppen, beldagen en
  het aandeel eigen relaties op de lijst
- marktomvang: ruim 1.600 IT-bedrijven, accountantskantoren en verzekeraars
  met vijftig of meer medewerkers, waarvan 540 benaderd
- correctie in het deck: werkperiode 1 was niet de warme lijst, vier van de
  vijf afspraken kwamen daar juist uit de koude lijst

Co-Authored-By: Claude Opus 5 <noreply@anthropic.com>
Claude-Session: https://claude.ai/code/session_0141FN3f3hHkYQHTyvTJJGrw
</commit_message>
<xml_diff>
--- a/output/LINK. voorstel OK Creative Agency.pptx
+++ b/output/LINK. voorstel OK Creative Agency.pptx
@@ -6628,7 +6628,7 @@
                 <a:ea typeface="Arial" pitchFamily="34" charset="-122"/>
                 <a:cs typeface="Arial" pitchFamily="34" charset="-120"/>
               </a:rPr>
-              <a:t>Je betaalt nu al ongeveer € 540 per beldag, alleen gaan er bijna vier in een werkperiode. Met een scherpere lijst lopen deze aantallen omhoog: bij de verhouding van jullie eigen relaties zitten er tien afspraken in zes beldagen.</a:t>
+              <a:t>Je betaalt nu al ongeveer € 540 per beldag, alleen gaan er bijna vier in een werkperiode. Groeit het aandeel eigen relaties op de lijst, dan lopen deze aantallen omhoog. Dat is de knop waar we samen aan draaien.</a:t>
             </a:r>
             <a:endParaRPr lang="en-US" sz="1200" dirty="0"/>
           </a:p>
@@ -7055,7 +7055,7 @@
                 <a:ea typeface="Arial" pitchFamily="34" charset="-122"/>
                 <a:cs typeface="Arial" pitchFamily="34" charset="-120"/>
               </a:rPr>
-              <a:t>De bedrijven waar Frits en Mark graag binnen willen komen, en de relaties van vroeger. Daar ligt het rendement drie keer zo hoog.</a:t>
+              <a:t>De bedrijven waar Frits en Mark graag binnen willen komen, en de relaties van vroeger. Op dat deel van de lijst ligt het rendement tot nu toe drie keer zo hoog.</a:t>
             </a:r>
             <a:endParaRPr lang="en-US" sz="1050" dirty="0"/>
           </a:p>
@@ -15391,7 +15391,7 @@
                 <a:ea typeface="Arial" pitchFamily="34" charset="-122"/>
                 <a:cs typeface="Arial" pitchFamily="34" charset="-120"/>
               </a:rPr>
-              <a:t>In werkperiode 1 belden we vooral jullie eigen relaties en gewenste klanten. Daarna ging het volume vier keer omhoog en het rendement vijf keer omlaag. Dat ligt niet aan het aantal gesprekken maar aan wie we belden.</a:t>
+              <a:t>Werkperiode 1 was een kleine periode: 200 pogingen en vijf afspraken. Daarna ging het volume vier en zes keer omhoog en zakte het rendement naar vijf per duizend. Het aantal gesprekken is dus niet het probleem.</a:t>
             </a:r>
             <a:endParaRPr lang="en-US" sz="1200" dirty="0"/>
           </a:p>
@@ -15635,7 +15635,7 @@
                 <a:ea typeface="Arial" pitchFamily="34" charset="-122"/>
                 <a:cs typeface="Arial" pitchFamily="34" charset="-120"/>
               </a:rPr>
-              <a:t>Dezelfde beller, dezelfde week, </a:t>
+              <a:t>De lijst met jullie eigen relaties loopt </a:t>
             </a:r>
             <a:pPr algn="l" indent="0" marL="0">
               <a:lnSpc>
@@ -15652,7 +15652,7 @@
                 <a:ea typeface="Georgia" pitchFamily="34" charset="-122"/>
                 <a:cs typeface="Georgia" pitchFamily="34" charset="-120"/>
               </a:rPr>
-              <a:t>drie keer zoveel resultaat</a:t>
+              <a:t>drie keer beter</a:t>
             </a:r>
             <a:pPr algn="l" indent="0" marL="0">
               <a:lnSpc>
@@ -16467,7 +16467,7 @@
                 <a:ea typeface="Arial" pitchFamily="34" charset="-122"/>
                 <a:cs typeface="Arial" pitchFamily="34" charset="-120"/>
               </a:rPr>
-              <a:t>Op de lijst met jullie eigen relaties en gewenste klanten kost een afspraak ongeveer € 207. Op de koude lijst € 667. Dit is het belangrijkste cijfer van de hele pilot.</a:t>
+              <a:t>Op de lijst met jullie relaties en gewenste klanten kost een afspraak ongeveer € 207, op de koude lijst € 667. Het gaat om vier afspraken uit 207 pogingen, dus het is een richting en geen zekerheid. Maar het is wel het enige signaal in de data dat zo hard is.</a:t>
             </a:r>
             <a:endParaRPr lang="en-US" sz="1200" dirty="0"/>
           </a:p>

</xml_diff>

<commit_message>
OK Creative: kosten per afspraak eruit, target 1,5 en markt op 15 fte
- prijs per afspraak uit deck en pagina gehaald, vervangen door pogingen per
  afspraak en bedrijven gesproken
- target 1,5 afspraak per beldag: vier beldagen zijn zes afspraken, precies
  het aantal uit de overeenkomst, bij een derde eigen relaties op de lijst
- marktomvang opnieuw gemeten vanaf ongeveer vijftien medewerkers: ruim 7.500
  bedrijven, waarvan 540 benaderd

Co-Authored-By: Claude Opus 5 <noreply@anthropic.com>
Claude-Session: https://claude.ai/code/session_0141FN3f3hHkYQHTyvTJJGrw
</commit_message>
<xml_diff>
--- a/output/LINK. voorstel OK Creative Agency.pptx
+++ b/output/LINK. voorstel OK Creative Agency.pptx
@@ -3608,7 +3608,7 @@
                 <a:ea typeface="Arial" pitchFamily="34" charset="-122"/>
                 <a:cs typeface="Arial" pitchFamily="34" charset="-120"/>
               </a:rPr>
-              <a:t>Een target dat klopt</a:t>
+              <a:t>Anderhalve afspraak per beldag</a:t>
             </a:r>
             <a:endParaRPr lang="en-US" sz="1150" dirty="0"/>
           </a:p>
@@ -3650,7 +3650,7 @@
                 <a:ea typeface="Arial" pitchFamily="34" charset="-122"/>
                 <a:cs typeface="Arial" pitchFamily="34" charset="-120"/>
               </a:rPr>
-              <a:t>Zes afspraken per maand vraagt zes beldagen, niet de bijna vier die er nu in gaan. Dat rekenen we voortaan vooraf uit in plaats van achteraf.</a:t>
+              <a:t>Daar mikken we op vanaf werkperiode 4. Vier beldagen zijn dan zes afspraken, precies het aantal dat in de overeenkomst staat.</a:t>
             </a:r>
             <a:endParaRPr lang="en-US" sz="875" dirty="0"/>
           </a:p>
@@ -4410,7 +4410,7 @@
                 <a:ea typeface="Arial" pitchFamily="34" charset="-122"/>
                 <a:cs typeface="Arial" pitchFamily="34" charset="-120"/>
               </a:rPr>
-              <a:t>Voorwerk per prospect inbegrepen</a:t>
+              <a:t>1,5 gekwalificeerde afspraak per beldag</a:t>
             </a:r>
             <a:endParaRPr lang="en-US" sz="900" dirty="0"/>
           </a:p>
@@ -4780,7 +4780,7 @@
                 <a:ea typeface="Arial" pitchFamily="34" charset="-122"/>
                 <a:cs typeface="Arial" pitchFamily="34" charset="-120"/>
               </a:rPr>
-              <a:t>Zes afspraken per maand vraagt </a:t>
+              <a:t>Zes afspraken per maand met </a:t>
             </a:r>
             <a:pPr algn="l" indent="0" marL="0">
               <a:lnSpc>
@@ -4797,7 +4797,7 @@
                 <a:ea typeface="Georgia" pitchFamily="34" charset="-122"/>
                 <a:cs typeface="Georgia" pitchFamily="34" charset="-120"/>
               </a:rPr>
-              <a:t>zes beldagen</a:t>
+              <a:t>vier beldagen</a:t>
             </a:r>
             <a:pPr algn="l" indent="0" marL="0">
               <a:lnSpc>
@@ -5502,7 +5502,7 @@
                 <a:ea typeface="Arial" pitchFamily="34" charset="-122"/>
                 <a:cs typeface="Arial" pitchFamily="34" charset="-120"/>
               </a:rPr>
-              <a:t>Zes beldagen</a:t>
+              <a:t>Vier beldagen</a:t>
             </a:r>
             <a:endParaRPr lang="en-US" sz="1250" dirty="0"/>
           </a:p>
@@ -5580,7 +5580,7 @@
                 <a:ea typeface="Arial" pitchFamily="34" charset="-122"/>
                 <a:cs typeface="Arial" pitchFamily="34" charset="-120"/>
               </a:rPr>
-              <a:t>6</a:t>
+              <a:t>4</a:t>
             </a:r>
             <a:endParaRPr lang="en-US" sz="1150" dirty="0"/>
           </a:p>
@@ -5681,7 +5681,7 @@
                 <a:ea typeface="Arial" pitchFamily="34" charset="-122"/>
                 <a:cs typeface="Arial" pitchFamily="34" charset="-120"/>
               </a:rPr>
-              <a:t>900</a:t>
+              <a:t>600</a:t>
             </a:r>
             <a:endParaRPr lang="en-US" sz="1150" dirty="0"/>
           </a:p>
@@ -5883,7 +5883,7 @@
                 <a:ea typeface="Arial" pitchFamily="34" charset="-122"/>
                 <a:cs typeface="Arial" pitchFamily="34" charset="-120"/>
               </a:rPr>
-              <a:t>€ 575</a:t>
+              <a:t>€ 600</a:t>
             </a:r>
             <a:endParaRPr lang="en-US" sz="1150" dirty="0"/>
           </a:p>
@@ -5984,7 +5984,7 @@
                 <a:ea typeface="Arial" pitchFamily="34" charset="-122"/>
                 <a:cs typeface="Arial" pitchFamily="34" charset="-120"/>
               </a:rPr>
-              <a:t>€ 3.450</a:t>
+              <a:t>€ 2.400</a:t>
             </a:r>
             <a:endParaRPr lang="en-US" sz="1150" dirty="0"/>
           </a:p>
@@ -6087,7 +6087,7 @@
                 <a:ea typeface="Arial" pitchFamily="34" charset="-122"/>
                 <a:cs typeface="Arial" pitchFamily="34" charset="-120"/>
               </a:rPr>
-              <a:t>Vier beldagen</a:t>
+              <a:t>Zes beldagen</a:t>
             </a:r>
             <a:endParaRPr lang="en-US" sz="1250" dirty="0"/>
           </a:p>
@@ -6165,7 +6165,7 @@
                 <a:ea typeface="Arial" pitchFamily="34" charset="-122"/>
                 <a:cs typeface="Arial" pitchFamily="34" charset="-120"/>
               </a:rPr>
-              <a:t>4</a:t>
+              <a:t>6</a:t>
             </a:r>
             <a:endParaRPr lang="en-US" sz="1150" dirty="0"/>
           </a:p>
@@ -6266,7 +6266,7 @@
                 <a:ea typeface="Arial" pitchFamily="34" charset="-122"/>
                 <a:cs typeface="Arial" pitchFamily="34" charset="-120"/>
               </a:rPr>
-              <a:t>600</a:t>
+              <a:t>900</a:t>
             </a:r>
             <a:endParaRPr lang="en-US" sz="1150" dirty="0"/>
           </a:p>
@@ -6367,7 +6367,7 @@
                 <a:ea typeface="Arial" pitchFamily="34" charset="-122"/>
                 <a:cs typeface="Arial" pitchFamily="34" charset="-120"/>
               </a:rPr>
-              <a:t>4</a:t>
+              <a:t>9</a:t>
             </a:r>
             <a:endParaRPr lang="en-US" sz="1150" dirty="0"/>
           </a:p>
@@ -6468,7 +6468,7 @@
                 <a:ea typeface="Arial" pitchFamily="34" charset="-122"/>
                 <a:cs typeface="Arial" pitchFamily="34" charset="-120"/>
               </a:rPr>
-              <a:t>€ 600</a:t>
+              <a:t>€ 575</a:t>
             </a:r>
             <a:endParaRPr lang="en-US" sz="1150" dirty="0"/>
           </a:p>
@@ -6569,7 +6569,7 @@
                 <a:ea typeface="Arial" pitchFamily="34" charset="-122"/>
                 <a:cs typeface="Arial" pitchFamily="34" charset="-120"/>
               </a:rPr>
-              <a:t>€ 2.400</a:t>
+              <a:t>€ 3.450</a:t>
             </a:r>
             <a:endParaRPr lang="en-US" sz="1150" dirty="0"/>
           </a:p>
@@ -6628,7 +6628,7 @@
                 <a:ea typeface="Arial" pitchFamily="34" charset="-122"/>
                 <a:cs typeface="Arial" pitchFamily="34" charset="-120"/>
               </a:rPr>
-              <a:t>Je betaalt nu al ongeveer € 540 per beldag, alleen gaan er bijna vier in een werkperiode. Groeit het aandeel eigen relaties op de lijst, dan lopen deze aantallen omhoog. Dat is de knop waar we samen aan draaien.</a:t>
+              <a:t>Je betaalt nu al ongeveer € 540 per beldag. Met vier beldagen en een derde eigen relaties op de lijst komen we op de zes afspraken per maand die in de overeenkomst staan. Wil je sneller, dan zijn het er negen bij zes beldagen.</a:t>
             </a:r>
             <a:endParaRPr lang="en-US" sz="1200" dirty="0"/>
           </a:p>
@@ -7055,7 +7055,7 @@
                 <a:ea typeface="Arial" pitchFamily="34" charset="-122"/>
                 <a:cs typeface="Arial" pitchFamily="34" charset="-120"/>
               </a:rPr>
-              <a:t>De bedrijven waar Frits en Mark graag binnen willen komen, en de relaties van vroeger. Op dat deel van de lijst ligt het rendement tot nu toe drie keer zo hoog.</a:t>
+              <a:t>De bedrijven waar Frits en Mark graag binnen willen komen, en de relaties van vroeger. Wij willen ongeveer een derde van de bellijst daaruit laten bestaan. Dat is wat het target van 1,5 haalbaar maakt.</a:t>
             </a:r>
             <a:endParaRPr lang="en-US" sz="1050" dirty="0"/>
           </a:p>
@@ -7992,7 +7992,7 @@
                 <a:ea typeface="Arial" pitchFamily="34" charset="-122"/>
                 <a:cs typeface="Arial" pitchFamily="34" charset="-120"/>
               </a:rPr>
-              <a:t>Target vooraf uitgerekend</a:t>
+              <a:t>1,5 afspraak per beldag</a:t>
             </a:r>
             <a:endParaRPr lang="en-US" sz="1200" dirty="0"/>
           </a:p>
@@ -8034,7 +8034,7 @@
                 <a:ea typeface="Arial" pitchFamily="34" charset="-122"/>
                 <a:cs typeface="Arial" pitchFamily="34" charset="-120"/>
               </a:rPr>
-              <a:t>Het aantal afspraken volgt uit het aantal beldagen en de mix van de lijst.</a:t>
+              <a:t>Het target waar we op sturen. Vier beldagen zijn zes afspraken per werkperiode.</a:t>
             </a:r>
             <a:endParaRPr lang="en-US" sz="950" dirty="0"/>
           </a:p>
@@ -16467,7 +16467,7 @@
                 <a:ea typeface="Arial" pitchFamily="34" charset="-122"/>
                 <a:cs typeface="Arial" pitchFamily="34" charset="-120"/>
               </a:rPr>
-              <a:t>Op de lijst met jullie relaties en gewenste klanten kost een afspraak ongeveer € 207, op de koude lijst € 667. Het gaat om vier afspraken uit 207 pogingen, dus het is een richting en geen zekerheid. Maar het is wel het enige signaal in de data dat zo hard is.</a:t>
+              <a:t>Op de lijst met jullie relaties en gewenste klanten ligt het rendement ruim drie keer hoger. Het gaat om vier afspraken uit 207 pogingen, dus het is een richting en geen zekerheid. Wel is het de knop waarmee we van 1,1 naar 1,5 afspraak per beldag komen: ongeveer een derde van de lijst uit jullie eigen relaties.</a:t>
             </a:r>
             <a:endParaRPr lang="en-US" sz="1200" dirty="0"/>
           </a:p>
@@ -17232,7 +17232,7 @@
                 <a:ea typeface="Arial" pitchFamily="34" charset="-122"/>
                 <a:cs typeface="Arial" pitchFamily="34" charset="-120"/>
               </a:rPr>
-              <a:t>1 tot 3</a:t>
+              <a:t>1,5</a:t>
             </a:r>
             <a:endParaRPr lang="en-US" sz="3600" dirty="0"/>
           </a:p>
@@ -17313,7 +17313,7 @@
                 <a:ea typeface="Arial" pitchFamily="34" charset="-122"/>
                 <a:cs typeface="Arial" pitchFamily="34" charset="-120"/>
               </a:rPr>
-              <a:t>Eén op de koude lijst, bijna drie op de lijst met jullie eigen relaties. De mix bepaalt het.</a:t>
+              <a:t>Waar we op mikken vanaf werkperiode 4. In de pilot stond het op 1,1 per beldag, de lijst met jullie eigen relaties op bijna 3.</a:t>
             </a:r>
             <a:endParaRPr lang="en-US" sz="950" dirty="0"/>
           </a:p>
@@ -17372,7 +17372,7 @@
                 <a:ea typeface="Arial" pitchFamily="34" charset="-122"/>
                 <a:cs typeface="Arial" pitchFamily="34" charset="-120"/>
               </a:rPr>
-              <a:t>Wij rekenen in beldagen en niet in uren, omdat een uur niets zegt over wat eruit komt. Deze aantallen komen uit jullie eigen pilot.</a:t>
+              <a:t>Wij rekenen in beldagen en niet in uren, omdat een uur niets zegt over wat eruit komt. Vier beldagen met dit target zijn zes afspraken per werkperiode, precies het aantal uit de overeenkomst.</a:t>
             </a:r>
             <a:endParaRPr lang="en-US" sz="1200" dirty="0"/>
           </a:p>

</xml_diff>

<commit_message>
OK Creative: verloopsectie constructief geformuleerd
De kop argumenteerde tegen het eigen voorstel. Nu staat de les centraal: het
volume ging omhoog terwijl de lijst kouder werd, en dat wijst de knop aan.

Co-Authored-By: Claude Opus 5 <noreply@anthropic.com>
Claude-Session: https://claude.ai/code/session_0141FN3f3hHkYQHTyvTJJGrw
</commit_message>
<xml_diff>
--- a/output/LINK. voorstel OK Creative Agency.pptx
+++ b/output/LINK. voorstel OK Creative Agency.pptx
@@ -14545,7 +14545,7 @@
                 <a:ea typeface="Arial" pitchFamily="34" charset="-122"/>
                 <a:cs typeface="Arial" pitchFamily="34" charset="-120"/>
               </a:rPr>
-              <a:t>Meer bellen leverde </a:t>
+              <a:t>Drie werkperiodes, en één duidelijke </a:t>
             </a:r>
             <a:pPr algn="l" indent="0" marL="0">
               <a:lnSpc>
@@ -14562,7 +14562,7 @@
                 <a:ea typeface="Georgia" pitchFamily="34" charset="-122"/>
                 <a:cs typeface="Georgia" pitchFamily="34" charset="-120"/>
               </a:rPr>
-              <a:t>niet meer afspraken</a:t>
+              <a:t>les</a:t>
             </a:r>
             <a:pPr algn="l" indent="0" marL="0">
               <a:lnSpc>
@@ -14579,7 +14579,7 @@
                 <a:ea typeface="Arial" pitchFamily="34" charset="-122"/>
                 <a:cs typeface="Arial" pitchFamily="34" charset="-120"/>
               </a:rPr>
-              <a:t> op.</a:t>
+              <a:t>.</a:t>
             </a:r>
             <a:endParaRPr lang="en-US" sz="3200" dirty="0"/>
           </a:p>
@@ -15391,7 +15391,7 @@
                 <a:ea typeface="Arial" pitchFamily="34" charset="-122"/>
                 <a:cs typeface="Arial" pitchFamily="34" charset="-120"/>
               </a:rPr>
-              <a:t>Werkperiode 1 was een kleine periode: 200 pogingen en vijf afspraken. Daarna ging het volume vier en zes keer omhoog en zakte het rendement naar vijf per duizend. Het aantal gesprekken is dus niet het probleem.</a:t>
+              <a:t>Werkperiode 1 was klein: 200 pogingen. Daarna ging het volume fors omhoog en werd de lijst tegelijk kouder. Dat verklaart het verschil in rendement en het wijst precies aan welke knop vanaf werkperiode 4 omhoog moet.</a:t>
             </a:r>
             <a:endParaRPr lang="en-US" sz="1200" dirty="0"/>
           </a:p>

</xml_diff>

<commit_message>
OK Creative: deck en pagina herschreven als verkoopstuk
- de twaalf geleverde bedrijven bij naam, met de aanleiding per bedrijf
- pijplijn van zestig wachtende gesprekken als eigen hoofdstuk
- interne lijstvergelijking en het verloop per werkperiode eruit
- cijfers positief gebracht: 452 gesprekken en 540 bedrijven die de naam nu
  kennen, een doel uit artikel 1.2 van de overeenkomst
- rekenmachine terug naar een knop: beldagen bij 1,5 afspraak per dag

Co-Authored-By: Claude Opus 5 <noreply@anthropic.com>
Claude-Session: https://claude.ai/code/session_0141FN3f3hHkYQHTyvTJJGrw
</commit_message>
<xml_diff>
--- a/output/LINK. voorstel OK Creative Agency.pptx
+++ b/output/LINK. voorstel OK Creative Agency.pptx
@@ -2875,7 +2875,7 @@
                 <a:ea typeface="Arial" pitchFamily="34" charset="-122"/>
                 <a:cs typeface="Arial" pitchFamily="34" charset="-120"/>
               </a:rPr>
-              <a:t>Twaalf weken bellen zit erop. In deze presentatie staat wat het heeft opgeleverd, wat de cijfers laten zien over welke lijst werkt, en hoe we het vanaf november willen inrichten.</a:t>
+              <a:t>Twaalf weken bellen zit erop. In deze presentatie staat wie er aan tafel is gekomen, wat er nu klaarstaat en hoe we het vanaf november willen inrichten.</a:t>
             </a:r>
             <a:endParaRPr lang="en-US" sz="1400" dirty="0"/>
           </a:p>
@@ -3952,7 +3952,7 @@
                 <a:ea typeface="Arial" pitchFamily="34" charset="-122"/>
                 <a:cs typeface="Arial" pitchFamily="34" charset="-120"/>
               </a:rPr>
-              <a:t>De lijst sturen we samen</a:t>
+              <a:t>De lijst bouwen we samen</a:t>
             </a:r>
             <a:endParaRPr lang="en-US" sz="1150" dirty="0"/>
           </a:p>
@@ -3994,7 +3994,7 @@
                 <a:ea typeface="Arial" pitchFamily="34" charset="-122"/>
                 <a:cs typeface="Arial" pitchFamily="34" charset="-120"/>
               </a:rPr>
-              <a:t>Elke werkperiode bepalen we vooraf hoeveel procent van de lijst uit jullie eigen relaties en gewenste klanten bestaat. Dat is de knop die het verschil maakt.</a:t>
+              <a:t>Elke werkperiode zetten we vooraf samen de bellijst op, met een vast deel namen die jullie zelf aandragen. Dat is wat het target van anderhalve afspraak per beldag haalbaar maakt.</a:t>
             </a:r>
             <a:endParaRPr lang="en-US" sz="875" dirty="0"/>
           </a:p>
@@ -7055,7 +7055,7 @@
                 <a:ea typeface="Arial" pitchFamily="34" charset="-122"/>
                 <a:cs typeface="Arial" pitchFamily="34" charset="-120"/>
               </a:rPr>
-              <a:t>De bedrijven waar Frits en Mark graag binnen willen komen, en de relaties van vroeger. Wij willen ongeveer een derde van de bellijst daaruit laten bestaan. Dat is wat het target van 1,5 haalbaar maakt.</a:t>
+              <a:t>De bedrijven waar Frits en Mark graag binnen willen komen, en de relaties van vroeger. ING en Verpact kwamen daaruit. Daar willen we er vanaf werkperiode 4 meer van op de lijst.</a:t>
             </a:r>
             <a:endParaRPr lang="en-US" sz="1050" dirty="0"/>
           </a:p>
@@ -10203,7 +10203,7 @@
                 <a:ea typeface="Arial" pitchFamily="34" charset="-122"/>
                 <a:cs typeface="Arial" pitchFamily="34" charset="-120"/>
               </a:rPr>
-              <a:t>Jullie markt is een van de moeilijkste die wij bellen. Zakelijke dienstverlening vanaf vijftig medewerkers betekent een receptie die afschermt en een beslisser die zelden zelf opneemt. Dat zie je terug in de cijfers, en juist daarom sturen we op de lijst.</a:t>
+              <a:t>Jullie markt is er een waarin één goed gesprek veel waard is. Een directeur of marketingverantwoordelijke bij een organisatie van deze omvang spreek je niet via een advertentie. Daar is de telefoon het enige kanaal dat erdoorheen komt, en dat is precies wat wij doen.</a:t>
             </a:r>
             <a:endParaRPr lang="en-US" sz="1350" dirty="0"/>
           </a:p>
@@ -13396,7 +13396,7 @@
                 <a:ea typeface="Arial" pitchFamily="34" charset="-122"/>
                 <a:cs typeface="Arial" pitchFamily="34" charset="-120"/>
               </a:rPr>
-              <a:t>Bij de start van werkperiode 4 leggen we deze drie samen opnieuw vast. In de overeenkomst stond dat die criteria vooraf bepaald zouden worden en dat is er niet scherp genoeg van gekomen.</a:t>
+              <a:t>Bij de start van werkperiode 4 leggen we deze drie samen scherp vast, inclusief de ondergrens in medewerkers. Hoe scherper die eis, hoe hoger het rendement per beldag.</a:t>
             </a:r>
             <a:endParaRPr lang="en-US" sz="1200" dirty="0"/>
           </a:p>
@@ -13657,7 +13657,7 @@
                 <a:ea typeface="Georgia" pitchFamily="34" charset="-122"/>
                 <a:cs typeface="Georgia" pitchFamily="34" charset="-120"/>
               </a:rPr>
-              <a:t>geteld in ons belsysteem</a:t>
+              <a:t>en wat er nu ligt</a:t>
             </a:r>
             <a:pPr algn="l" indent="0" marL="0">
               <a:lnSpc>
@@ -13735,7 +13735,7 @@
                 <a:ea typeface="Arial" pitchFamily="34" charset="-122"/>
                 <a:cs typeface="Arial" pitchFamily="34" charset="-120"/>
               </a:rPr>
-              <a:t>1.668</a:t>
+              <a:t>452</a:t>
             </a:r>
             <a:endParaRPr lang="en-US" sz="3600" dirty="0"/>
           </a:p>
@@ -13774,7 +13774,7 @@
                 <a:ea typeface="Arial" pitchFamily="34" charset="-122"/>
                 <a:cs typeface="Arial" pitchFamily="34" charset="-120"/>
               </a:rPr>
-              <a:t>CONTACTPOGINGEN</a:t>
+              <a:t>GESPREKKEN MET DE DOELGROEP</a:t>
             </a:r>
             <a:endParaRPr lang="en-US" sz="900" dirty="0"/>
           </a:p>
@@ -13816,7 +13816,7 @@
                 <a:ea typeface="Arial" pitchFamily="34" charset="-122"/>
                 <a:cs typeface="Arial" pitchFamily="34" charset="-120"/>
               </a:rPr>
-              <a:t>Van 24 juli tot en met 9 oktober, verdeeld over 540 bedrijven.</a:t>
+              <a:t>Directeuren, MT-leden en marketingverantwoordelijken, persoonlijk aan de lijn gehad.</a:t>
             </a:r>
             <a:endParaRPr lang="en-US" sz="950" dirty="0"/>
           </a:p>
@@ -13877,7 +13877,7 @@
                 <a:ea typeface="Arial" pitchFamily="34" charset="-122"/>
                 <a:cs typeface="Arial" pitchFamily="34" charset="-120"/>
               </a:rPr>
-              <a:t>452</a:t>
+              <a:t>540</a:t>
             </a:r>
             <a:endParaRPr lang="en-US" sz="3600" dirty="0"/>
           </a:p>
@@ -13916,7 +13916,7 @@
                 <a:ea typeface="Arial" pitchFamily="34" charset="-122"/>
                 <a:cs typeface="Arial" pitchFamily="34" charset="-120"/>
               </a:rPr>
-              <a:t>BEDRIJVEN GESPROKEN</a:t>
+              <a:t>BEDRIJVEN KENNEN DE NAAM</a:t>
             </a:r>
             <a:endParaRPr lang="en-US" sz="900" dirty="0"/>
           </a:p>
@@ -13958,7 +13958,7 @@
                 <a:ea typeface="Arial" pitchFamily="34" charset="-122"/>
                 <a:cs typeface="Arial" pitchFamily="34" charset="-120"/>
               </a:rPr>
-              <a:t>Bij de rest kwamen we niet langs de receptie of was het nummer onjuist.</a:t>
+              <a:t>Allemaal benaderd namens oké. Voor een naam die vorig jaar nog Onze Kapel heette is dat op zichzelf waarde.</a:t>
             </a:r>
             <a:endParaRPr lang="en-US" sz="950" dirty="0"/>
           </a:p>
@@ -14058,7 +14058,7 @@
                 <a:ea typeface="Arial" pitchFamily="34" charset="-122"/>
                 <a:cs typeface="Arial" pitchFamily="34" charset="-120"/>
               </a:rPr>
-              <a:t>WARM EN OPEN</a:t>
+              <a:t>WARME CONTACTEN OPEN</a:t>
             </a:r>
             <a:endParaRPr lang="en-US" sz="900" dirty="0"/>
           </a:p>
@@ -14100,7 +14100,7 @@
                 <a:ea typeface="Arial" pitchFamily="34" charset="-122"/>
                 <a:cs typeface="Arial" pitchFamily="34" charset="-120"/>
               </a:rPr>
-              <a:t>Terugbelafspraken en verstuurde introducties die nog lopen.</a:t>
+              <a:t>Terugbelafspraken en introducties die nog lopen, met naam, reden en datum erbij.</a:t>
             </a:r>
             <a:endParaRPr lang="en-US" sz="950" dirty="0"/>
           </a:p>
@@ -14242,7 +14242,7 @@
                 <a:ea typeface="Arial" pitchFamily="34" charset="-122"/>
                 <a:cs typeface="Arial" pitchFamily="34" charset="-120"/>
               </a:rPr>
-              <a:t>Zeven ingeplande afspraken en vijf overdrachten. Eén per 139 pogingen.</a:t>
+              <a:t>Zeven ingeplande afspraken voor Frits en vijf leads rechtstreeks overgedragen.</a:t>
             </a:r>
             <a:endParaRPr lang="en-US" sz="950" dirty="0"/>
           </a:p>
@@ -14301,7 +14301,7 @@
                 <a:ea typeface="Arial" pitchFamily="34" charset="-122"/>
                 <a:cs typeface="Arial" pitchFamily="34" charset="-120"/>
               </a:rPr>
-              <a:t>Deze cijfers komen uit de belexport van 11 oktober, niet uit een schatting. Werkperiode 3 loopt nog door tot 25 oktober.</a:t>
+              <a:t>Deze cijfers komen uit de belexport van 11 oktober. Werkperiode 3 loopt nog door tot 25 oktober, dus hier komt nog bij.</a:t>
             </a:r>
             <a:endParaRPr lang="en-US" sz="1200" dirty="0"/>
           </a:p>
@@ -14321,7 +14321,7 @@
     <p:bg>
       <p:bgPr>
         <a:solidFill>
-          <a:srgbClr val="141821"/>
+          <a:srgbClr val="E9E0CD"/>
         </a:solidFill>
       </p:bgPr>
     </p:bg>
@@ -14366,7 +14366,7 @@
             <a:r>
               <a:rPr lang="en-US" sz="1800" b="1" dirty="0">
                 <a:solidFill>
-                  <a:srgbClr val="F2EFE6"/>
+                  <a:srgbClr val="1C2230"/>
                 </a:solidFill>
                 <a:latin typeface="Arial" pitchFamily="34" charset="0"/>
                 <a:ea typeface="Arial" pitchFamily="34" charset="-122"/>
@@ -14419,7 +14419,7 @@
             <a:r>
               <a:rPr lang="en-US" sz="750" b="1" spc="100" kern="0" dirty="0">
                 <a:solidFill>
-                  <a:srgbClr val="BDC3CE"/>
+                  <a:srgbClr val="6F6A5C"/>
                 </a:solidFill>
                 <a:latin typeface="Arial" pitchFamily="34" charset="0"/>
                 <a:ea typeface="Arial" pitchFamily="34" charset="-122"/>
@@ -14458,7 +14458,7 @@
             <a:r>
               <a:rPr lang="en-US" sz="750" b="1" spc="100" kern="0" dirty="0">
                 <a:solidFill>
-                  <a:srgbClr val="BDC3CE"/>
+                  <a:srgbClr val="6F6A5C"/>
                 </a:solidFill>
                 <a:latin typeface="Arial" pitchFamily="34" charset="0"/>
                 <a:ea typeface="Arial" pitchFamily="34" charset="-122"/>
@@ -14503,7 +14503,7 @@
                 <a:ea typeface="Arial" pitchFamily="34" charset="-122"/>
                 <a:cs typeface="Arial" pitchFamily="34" charset="-120"/>
               </a:rPr>
-              <a:t>HET VERLOOP</a:t>
+              <a:t>WIE ER AAN TAFEL KWAM</a:t>
             </a:r>
             <a:endParaRPr lang="en-US" sz="950" dirty="0"/>
           </a:p>
@@ -14539,13 +14539,13 @@
             <a:r>
               <a:rPr lang="en-US" sz="3200" b="1" dirty="0">
                 <a:solidFill>
-                  <a:srgbClr val="F2EFE6"/>
-                </a:solidFill>
-                <a:latin typeface="Arial" pitchFamily="34" charset="0"/>
-                <a:ea typeface="Arial" pitchFamily="34" charset="-122"/>
-                <a:cs typeface="Arial" pitchFamily="34" charset="-120"/>
-              </a:rPr>
-              <a:t>Drie werkperiodes, en één duidelijke </a:t>
+                  <a:srgbClr val="1C2230"/>
+                </a:solidFill>
+                <a:latin typeface="Arial" pitchFamily="34" charset="0"/>
+                <a:ea typeface="Arial" pitchFamily="34" charset="-122"/>
+                <a:cs typeface="Arial" pitchFamily="34" charset="-120"/>
+              </a:rPr>
+              <a:t>Twaalf bedrijven, waaronder deze </a:t>
             </a:r>
             <a:pPr algn="l" indent="0" marL="0">
               <a:lnSpc>
@@ -14556,13 +14556,13 @@
             <a:r>
               <a:rPr lang="en-US" sz="3000" i="1" dirty="0">
                 <a:solidFill>
-                  <a:srgbClr val="F2EFE6"/>
+                  <a:srgbClr val="1C2230"/>
                 </a:solidFill>
                 <a:latin typeface="Georgia" pitchFamily="34" charset="0"/>
                 <a:ea typeface="Georgia" pitchFamily="34" charset="-122"/>
                 <a:cs typeface="Georgia" pitchFamily="34" charset="-120"/>
               </a:rPr>
-              <a:t>les</a:t>
+              <a:t>drie</a:t>
             </a:r>
             <a:pPr algn="l" indent="0" marL="0">
               <a:lnSpc>
@@ -14573,7 +14573,7 @@
             <a:r>
               <a:rPr lang="en-US" sz="3200" b="1" dirty="0">
                 <a:solidFill>
-                  <a:srgbClr val="F2EFE6"/>
+                  <a:srgbClr val="1C2230"/>
                 </a:solidFill>
                 <a:latin typeface="Arial" pitchFamily="34" charset="0"/>
                 <a:ea typeface="Arial" pitchFamily="34" charset="-122"/>
@@ -14593,48 +14593,593 @@
         </p:nvSpPr>
         <p:spPr>
           <a:xfrm>
-            <a:off x="609598" y="2666993"/>
-            <a:ext cx="10972773" cy="2355844"/>
+            <a:off x="609598" y="2793993"/>
+            <a:ext cx="2628893" cy="3238492"/>
           </a:xfrm>
           <a:prstGeom prst="roundRect">
             <a:avLst>
-              <a:gd name="adj" fmla="val 4313"/>
+              <a:gd name="adj" fmla="val 3865"/>
             </a:avLst>
           </a:prstGeom>
-          <a:ln w="9525">
-            <a:solidFill>
-              <a:srgbClr val="3A4152"/>
-            </a:solidFill>
-            <a:prstDash val="solid"/>
-          </a:ln>
-        </p:spPr>
-      </p:sp>
-      <p:sp>
-        <p:nvSpPr>
-          <p:cNvPr id="8" name="Text 6"/>
-          <p:cNvSpPr txBox="1"/>
-          <p:nvPr/>
-        </p:nvSpPr>
-        <p:spPr>
-          <a:xfrm>
-            <a:off x="888998" y="2666993"/>
-            <a:ext cx="2920993" cy="469899"/>
-          </a:xfrm>
-          <a:prstGeom prst="rect">
-            <a:avLst/>
-          </a:prstGeom>
-          <a:noFill/>
-          <a:ln/>
-        </p:spPr>
-        <p:txBody>
-          <a:bodyPr wrap="square" lIns="0" tIns="0" rIns="0" bIns="0" rtlCol="0" anchor="ctr"/>
+          <a:solidFill>
+            <a:srgbClr val="F8F4EB"/>
+          </a:solidFill>
+          <a:ln/>
+        </p:spPr>
+      </p:sp>
+      <p:sp>
+        <p:nvSpPr>
+          <p:cNvPr id="8" name="Shape 6"/>
+          <p:cNvSpPr/>
+          <p:nvPr/>
+        </p:nvSpPr>
+        <p:spPr>
+          <a:xfrm>
+            <a:off x="863598" y="3073392"/>
+            <a:ext cx="380999" cy="380999"/>
+          </a:xfrm>
+          <a:prstGeom prst="roundRect">
+            <a:avLst>
+              <a:gd name="adj" fmla="val 23333"/>
+            </a:avLst>
+          </a:prstGeom>
+          <a:solidFill>
+            <a:srgbClr val="DDEBF3"/>
+          </a:solidFill>
+          <a:ln/>
+        </p:spPr>
+      </p:sp>
+      <p:pic>
+        <p:nvPicPr>
+          <p:cNvPr id="9" name="Image 0" descr="preencoded.png">    </p:cNvPr>
+          <p:cNvPicPr>
+            <a:picLocks noChangeAspect="1"/>
+          </p:cNvPicPr>
+          <p:nvPr/>
+        </p:nvPicPr>
+        <p:blipFill>
+          <a:blip r:embed="rId1"/>
+          <a:stretch>
+            <a:fillRect/>
+          </a:stretch>
+        </p:blipFill>
+        <p:spPr>
+          <a:xfrm>
+            <a:off x="958848" y="3168642"/>
+            <a:ext cx="190500" cy="190500"/>
+          </a:xfrm>
+          <a:prstGeom prst="rect">
+            <a:avLst/>
+          </a:prstGeom>
+        </p:spPr>
+      </p:pic>
+      <p:sp>
+        <p:nvSpPr>
+          <p:cNvPr id="10" name="Text 7"/>
+          <p:cNvSpPr txBox="1"/>
+          <p:nvPr/>
+        </p:nvSpPr>
+        <p:spPr>
+          <a:xfrm>
+            <a:off x="863598" y="3632191"/>
+            <a:ext cx="2120895" cy="533399"/>
+          </a:xfrm>
+          <a:prstGeom prst="rect">
+            <a:avLst/>
+          </a:prstGeom>
+          <a:noFill/>
+          <a:ln/>
+        </p:spPr>
+        <p:txBody>
+          <a:bodyPr wrap="square" lIns="0" tIns="0" rIns="0" bIns="0" rtlCol="0" anchor="t"/>
           <a:lstStyle/>
           <a:p>
             <a:pPr indent="0" marL="0">
-              <a:buNone/>
-            </a:pPr>
-            <a:r>
-              <a:rPr lang="en-US" sz="800" b="1" spc="160" kern="0" dirty="0">
+              <a:lnSpc>
+                <a:spcPct val="115000"/>
+              </a:lnSpc>
+              <a:buNone/>
+            </a:pPr>
+            <a:r>
+              <a:rPr lang="en-US" sz="1350" b="1" dirty="0">
+                <a:solidFill>
+                  <a:srgbClr val="1C2230"/>
+                </a:solidFill>
+                <a:latin typeface="Arial" pitchFamily="34" charset="0"/>
+                <a:ea typeface="Arial" pitchFamily="34" charset="-122"/>
+                <a:cs typeface="Arial" pitchFamily="34" charset="-120"/>
+              </a:rPr>
+              <a:t>ING</a:t>
+            </a:r>
+            <a:endParaRPr lang="en-US" sz="1350" dirty="0"/>
+          </a:p>
+        </p:txBody>
+      </p:sp>
+      <p:sp>
+        <p:nvSpPr>
+          <p:cNvPr id="11" name="Text 8"/>
+          <p:cNvSpPr txBox="1"/>
+          <p:nvPr/>
+        </p:nvSpPr>
+        <p:spPr>
+          <a:xfrm>
+            <a:off x="863598" y="4203689"/>
+            <a:ext cx="2120895" cy="1587496"/>
+          </a:xfrm>
+          <a:prstGeom prst="rect">
+            <a:avLst/>
+          </a:prstGeom>
+          <a:noFill/>
+          <a:ln/>
+        </p:spPr>
+        <p:txBody>
+          <a:bodyPr wrap="square" lIns="0" tIns="0" rIns="0" bIns="0" rtlCol="0" anchor="t"/>
+          <a:lstStyle/>
+          <a:p>
+            <a:pPr indent="0" marL="0">
+              <a:lnSpc>
+                <a:spcPct val="135000"/>
+              </a:lnSpc>
+              <a:buNone/>
+            </a:pPr>
+            <a:r>
+              <a:rPr lang="en-US" sz="950" dirty="0">
+                <a:solidFill>
+                  <a:srgbClr val="6F6A5C"/>
+                </a:solidFill>
+                <a:latin typeface="Arial" pitchFamily="34" charset="0"/>
+                <a:ea typeface="Arial" pitchFamily="34" charset="-122"/>
+                <a:cs typeface="Arial" pitchFamily="34" charset="-120"/>
+              </a:rPr>
+              <a:t>Reageerde op de mail vanuit oké. Ellen wil online sparren. Gekomen uit jullie eigen lijst met gewenste klanten.</a:t>
+            </a:r>
+            <a:endParaRPr lang="en-US" sz="950" dirty="0"/>
+          </a:p>
+        </p:txBody>
+      </p:sp>
+      <p:sp>
+        <p:nvSpPr>
+          <p:cNvPr id="12" name="Shape 9"/>
+          <p:cNvSpPr/>
+          <p:nvPr/>
+        </p:nvSpPr>
+        <p:spPr>
+          <a:xfrm>
+            <a:off x="3390892" y="2793993"/>
+            <a:ext cx="2628893" cy="3238492"/>
+          </a:xfrm>
+          <a:prstGeom prst="roundRect">
+            <a:avLst>
+              <a:gd name="adj" fmla="val 3865"/>
+            </a:avLst>
+          </a:prstGeom>
+          <a:solidFill>
+            <a:srgbClr val="F8F4EB"/>
+          </a:solidFill>
+          <a:ln/>
+        </p:spPr>
+      </p:sp>
+      <p:sp>
+        <p:nvSpPr>
+          <p:cNvPr id="13" name="Shape 10"/>
+          <p:cNvSpPr/>
+          <p:nvPr/>
+        </p:nvSpPr>
+        <p:spPr>
+          <a:xfrm>
+            <a:off x="3644891" y="3073392"/>
+            <a:ext cx="380999" cy="380999"/>
+          </a:xfrm>
+          <a:prstGeom prst="roundRect">
+            <a:avLst>
+              <a:gd name="adj" fmla="val 23333"/>
+            </a:avLst>
+          </a:prstGeom>
+          <a:solidFill>
+            <a:srgbClr val="DDEBF3"/>
+          </a:solidFill>
+          <a:ln/>
+        </p:spPr>
+      </p:sp>
+      <p:pic>
+        <p:nvPicPr>
+          <p:cNvPr id="14" name="Image 1" descr="preencoded.png">    </p:cNvPr>
+          <p:cNvPicPr>
+            <a:picLocks noChangeAspect="1"/>
+          </p:cNvPicPr>
+          <p:nvPr/>
+        </p:nvPicPr>
+        <p:blipFill>
+          <a:blip r:embed="rId2"/>
+          <a:stretch>
+            <a:fillRect/>
+          </a:stretch>
+        </p:blipFill>
+        <p:spPr>
+          <a:xfrm>
+            <a:off x="3740141" y="3168642"/>
+            <a:ext cx="190500" cy="190500"/>
+          </a:xfrm>
+          <a:prstGeom prst="rect">
+            <a:avLst/>
+          </a:prstGeom>
+        </p:spPr>
+      </p:pic>
+      <p:sp>
+        <p:nvSpPr>
+          <p:cNvPr id="15" name="Text 11"/>
+          <p:cNvSpPr txBox="1"/>
+          <p:nvPr/>
+        </p:nvSpPr>
+        <p:spPr>
+          <a:xfrm>
+            <a:off x="3644891" y="3632191"/>
+            <a:ext cx="2120895" cy="533399"/>
+          </a:xfrm>
+          <a:prstGeom prst="rect">
+            <a:avLst/>
+          </a:prstGeom>
+          <a:noFill/>
+          <a:ln/>
+        </p:spPr>
+        <p:txBody>
+          <a:bodyPr wrap="square" lIns="0" tIns="0" rIns="0" bIns="0" rtlCol="0" anchor="t"/>
+          <a:lstStyle/>
+          <a:p>
+            <a:pPr indent="0" marL="0">
+              <a:lnSpc>
+                <a:spcPct val="115000"/>
+              </a:lnSpc>
+              <a:buNone/>
+            </a:pPr>
+            <a:r>
+              <a:rPr lang="en-US" sz="1350" b="1" dirty="0">
+                <a:solidFill>
+                  <a:srgbClr val="1C2230"/>
+                </a:solidFill>
+                <a:latin typeface="Arial" pitchFamily="34" charset="0"/>
+                <a:ea typeface="Arial" pitchFamily="34" charset="-122"/>
+                <a:cs typeface="Arial" pitchFamily="34" charset="-120"/>
+              </a:rPr>
+              <a:t>Iv-Consult</a:t>
+            </a:r>
+            <a:endParaRPr lang="en-US" sz="1350" dirty="0"/>
+          </a:p>
+        </p:txBody>
+      </p:sp>
+      <p:sp>
+        <p:nvSpPr>
+          <p:cNvPr id="16" name="Text 12"/>
+          <p:cNvSpPr txBox="1"/>
+          <p:nvPr/>
+        </p:nvSpPr>
+        <p:spPr>
+          <a:xfrm>
+            <a:off x="3644891" y="4203689"/>
+            <a:ext cx="2120895" cy="1587496"/>
+          </a:xfrm>
+          <a:prstGeom prst="rect">
+            <a:avLst/>
+          </a:prstGeom>
+          <a:noFill/>
+          <a:ln/>
+        </p:spPr>
+        <p:txBody>
+          <a:bodyPr wrap="square" lIns="0" tIns="0" rIns="0" bIns="0" rtlCol="0" anchor="t"/>
+          <a:lstStyle/>
+          <a:p>
+            <a:pPr indent="0" marL="0">
+              <a:lnSpc>
+                <a:spcPct val="135000"/>
+              </a:lnSpc>
+              <a:buNone/>
+            </a:pPr>
+            <a:r>
+              <a:rPr lang="en-US" sz="950" dirty="0">
+                <a:solidFill>
+                  <a:srgbClr val="6F6A5C"/>
+                </a:solidFill>
+                <a:latin typeface="Arial" pitchFamily="34" charset="0"/>
+                <a:ea typeface="Arial" pitchFamily="34" charset="-122"/>
+                <a:cs typeface="Arial" pitchFamily="34" charset="-120"/>
+              </a:rPr>
+              <a:t>22 oktober om 14:00 met Marieke de Groot. Koud benaderd, zij nam zelf contact op om kennis te maken.</a:t>
+            </a:r>
+            <a:endParaRPr lang="en-US" sz="950" dirty="0"/>
+          </a:p>
+        </p:txBody>
+      </p:sp>
+      <p:sp>
+        <p:nvSpPr>
+          <p:cNvPr id="17" name="Shape 13"/>
+          <p:cNvSpPr/>
+          <p:nvPr/>
+        </p:nvSpPr>
+        <p:spPr>
+          <a:xfrm>
+            <a:off x="6172185" y="2793993"/>
+            <a:ext cx="2628893" cy="3238492"/>
+          </a:xfrm>
+          <a:prstGeom prst="roundRect">
+            <a:avLst>
+              <a:gd name="adj" fmla="val 3865"/>
+            </a:avLst>
+          </a:prstGeom>
+          <a:solidFill>
+            <a:srgbClr val="F8F4EB"/>
+          </a:solidFill>
+          <a:ln/>
+        </p:spPr>
+      </p:sp>
+      <p:sp>
+        <p:nvSpPr>
+          <p:cNvPr id="18" name="Shape 14"/>
+          <p:cNvSpPr/>
+          <p:nvPr/>
+        </p:nvSpPr>
+        <p:spPr>
+          <a:xfrm>
+            <a:off x="6426184" y="3073392"/>
+            <a:ext cx="380999" cy="380999"/>
+          </a:xfrm>
+          <a:prstGeom prst="roundRect">
+            <a:avLst>
+              <a:gd name="adj" fmla="val 23333"/>
+            </a:avLst>
+          </a:prstGeom>
+          <a:solidFill>
+            <a:srgbClr val="DDEBF3"/>
+          </a:solidFill>
+          <a:ln/>
+        </p:spPr>
+      </p:sp>
+      <p:pic>
+        <p:nvPicPr>
+          <p:cNvPr id="19" name="Image 2" descr="preencoded.png">    </p:cNvPr>
+          <p:cNvPicPr>
+            <a:picLocks noChangeAspect="1"/>
+          </p:cNvPicPr>
+          <p:nvPr/>
+        </p:nvPicPr>
+        <p:blipFill>
+          <a:blip r:embed="rId3"/>
+          <a:stretch>
+            <a:fillRect/>
+          </a:stretch>
+        </p:blipFill>
+        <p:spPr>
+          <a:xfrm>
+            <a:off x="6521434" y="3168642"/>
+            <a:ext cx="190500" cy="190500"/>
+          </a:xfrm>
+          <a:prstGeom prst="rect">
+            <a:avLst/>
+          </a:prstGeom>
+        </p:spPr>
+      </p:pic>
+      <p:sp>
+        <p:nvSpPr>
+          <p:cNvPr id="20" name="Text 15"/>
+          <p:cNvSpPr txBox="1"/>
+          <p:nvPr/>
+        </p:nvSpPr>
+        <p:spPr>
+          <a:xfrm>
+            <a:off x="6426184" y="3632191"/>
+            <a:ext cx="2120895" cy="533399"/>
+          </a:xfrm>
+          <a:prstGeom prst="rect">
+            <a:avLst/>
+          </a:prstGeom>
+          <a:noFill/>
+          <a:ln/>
+        </p:spPr>
+        <p:txBody>
+          <a:bodyPr wrap="square" lIns="0" tIns="0" rIns="0" bIns="0" rtlCol="0" anchor="t"/>
+          <a:lstStyle/>
+          <a:p>
+            <a:pPr indent="0" marL="0">
+              <a:lnSpc>
+                <a:spcPct val="115000"/>
+              </a:lnSpc>
+              <a:buNone/>
+            </a:pPr>
+            <a:r>
+              <a:rPr lang="en-US" sz="1350" b="1" dirty="0">
+                <a:solidFill>
+                  <a:srgbClr val="1C2230"/>
+                </a:solidFill>
+                <a:latin typeface="Arial" pitchFamily="34" charset="0"/>
+                <a:ea typeface="Arial" pitchFamily="34" charset="-122"/>
+                <a:cs typeface="Arial" pitchFamily="34" charset="-120"/>
+              </a:rPr>
+              <a:t>Danieli Corus</a:t>
+            </a:r>
+            <a:endParaRPr lang="en-US" sz="1350" dirty="0"/>
+          </a:p>
+        </p:txBody>
+      </p:sp>
+      <p:sp>
+        <p:nvSpPr>
+          <p:cNvPr id="21" name="Text 16"/>
+          <p:cNvSpPr txBox="1"/>
+          <p:nvPr/>
+        </p:nvSpPr>
+        <p:spPr>
+          <a:xfrm>
+            <a:off x="6426184" y="4203689"/>
+            <a:ext cx="2120895" cy="1587496"/>
+          </a:xfrm>
+          <a:prstGeom prst="rect">
+            <a:avLst/>
+          </a:prstGeom>
+          <a:noFill/>
+          <a:ln/>
+        </p:spPr>
+        <p:txBody>
+          <a:bodyPr wrap="square" lIns="0" tIns="0" rIns="0" bIns="0" rtlCol="0" anchor="t"/>
+          <a:lstStyle/>
+          <a:p>
+            <a:pPr indent="0" marL="0">
+              <a:lnSpc>
+                <a:spcPct val="135000"/>
+              </a:lnSpc>
+              <a:buNone/>
+            </a:pPr>
+            <a:r>
+              <a:rPr lang="en-US" sz="950" dirty="0">
+                <a:solidFill>
+                  <a:srgbClr val="6F6A5C"/>
+                </a:solidFill>
+                <a:latin typeface="Arial" pitchFamily="34" charset="0"/>
+                <a:ea typeface="Arial" pitchFamily="34" charset="-122"/>
+                <a:cs typeface="Arial" pitchFamily="34" charset="-120"/>
+              </a:rPr>
+              <a:t>Edo Engel, marketingmanager Nederland, met een concrete vraag. Koud benaderd en direct overgedragen.</a:t>
+            </a:r>
+            <a:endParaRPr lang="en-US" sz="950" dirty="0"/>
+          </a:p>
+        </p:txBody>
+      </p:sp>
+      <p:sp>
+        <p:nvSpPr>
+          <p:cNvPr id="22" name="Shape 17"/>
+          <p:cNvSpPr/>
+          <p:nvPr/>
+        </p:nvSpPr>
+        <p:spPr>
+          <a:xfrm>
+            <a:off x="8953478" y="2793993"/>
+            <a:ext cx="2628893" cy="3238492"/>
+          </a:xfrm>
+          <a:prstGeom prst="roundRect">
+            <a:avLst>
+              <a:gd name="adj" fmla="val 3865"/>
+            </a:avLst>
+          </a:prstGeom>
+          <a:solidFill>
+            <a:srgbClr val="000000"/>
+          </a:solidFill>
+          <a:ln/>
+        </p:spPr>
+      </p:sp>
+      <p:sp>
+        <p:nvSpPr>
+          <p:cNvPr id="23" name="Shape 18"/>
+          <p:cNvSpPr/>
+          <p:nvPr/>
+        </p:nvSpPr>
+        <p:spPr>
+          <a:xfrm>
+            <a:off x="9207477" y="3073392"/>
+            <a:ext cx="380999" cy="380999"/>
+          </a:xfrm>
+          <a:prstGeom prst="roundRect">
+            <a:avLst>
+              <a:gd name="adj" fmla="val 23333"/>
+            </a:avLst>
+          </a:prstGeom>
+          <a:solidFill>
+            <a:srgbClr val="203C55"/>
+          </a:solidFill>
+          <a:ln/>
+        </p:spPr>
+      </p:sp>
+      <p:pic>
+        <p:nvPicPr>
+          <p:cNvPr id="24" name="Image 3" descr="preencoded.png">    </p:cNvPr>
+          <p:cNvPicPr>
+            <a:picLocks noChangeAspect="1"/>
+          </p:cNvPicPr>
+          <p:nvPr/>
+        </p:nvPicPr>
+        <p:blipFill>
+          <a:blip r:embed="rId4"/>
+          <a:stretch>
+            <a:fillRect/>
+          </a:stretch>
+        </p:blipFill>
+        <p:spPr>
+          <a:xfrm>
+            <a:off x="9302727" y="3168642"/>
+            <a:ext cx="190500" cy="190500"/>
+          </a:xfrm>
+          <a:prstGeom prst="rect">
+            <a:avLst/>
+          </a:prstGeom>
+        </p:spPr>
+      </p:pic>
+      <p:sp>
+        <p:nvSpPr>
+          <p:cNvPr id="25" name="Text 19"/>
+          <p:cNvSpPr txBox="1"/>
+          <p:nvPr/>
+        </p:nvSpPr>
+        <p:spPr>
+          <a:xfrm>
+            <a:off x="9207477" y="3632191"/>
+            <a:ext cx="2120895" cy="533399"/>
+          </a:xfrm>
+          <a:prstGeom prst="rect">
+            <a:avLst/>
+          </a:prstGeom>
+          <a:noFill/>
+          <a:ln/>
+        </p:spPr>
+        <p:txBody>
+          <a:bodyPr wrap="square" lIns="0" tIns="0" rIns="0" bIns="0" rtlCol="0" anchor="t"/>
+          <a:lstStyle/>
+          <a:p>
+            <a:pPr indent="0" marL="0">
+              <a:lnSpc>
+                <a:spcPct val="115000"/>
+              </a:lnSpc>
+              <a:buNone/>
+            </a:pPr>
+            <a:r>
+              <a:rPr lang="en-US" sz="1350" b="1" dirty="0">
+                <a:solidFill>
+                  <a:srgbClr val="FFFFFF"/>
+                </a:solidFill>
+                <a:latin typeface="Arial" pitchFamily="34" charset="0"/>
+                <a:ea typeface="Arial" pitchFamily="34" charset="-122"/>
+                <a:cs typeface="Arial" pitchFamily="34" charset="-120"/>
+              </a:rPr>
+              <a:t>En negen andere</a:t>
+            </a:r>
+            <a:endParaRPr lang="en-US" sz="1350" dirty="0"/>
+          </a:p>
+        </p:txBody>
+      </p:sp>
+      <p:sp>
+        <p:nvSpPr>
+          <p:cNvPr id="26" name="Text 20"/>
+          <p:cNvSpPr txBox="1"/>
+          <p:nvPr/>
+        </p:nvSpPr>
+        <p:spPr>
+          <a:xfrm>
+            <a:off x="9207477" y="4203689"/>
+            <a:ext cx="2120895" cy="1587496"/>
+          </a:xfrm>
+          <a:prstGeom prst="rect">
+            <a:avLst/>
+          </a:prstGeom>
+          <a:noFill/>
+          <a:ln/>
+        </p:spPr>
+        <p:txBody>
+          <a:bodyPr wrap="square" lIns="0" tIns="0" rIns="0" bIns="0" rtlCol="0" anchor="t"/>
+          <a:lstStyle/>
+          <a:p>
+            <a:pPr indent="0" marL="0">
+              <a:lnSpc>
+                <a:spcPct val="135000"/>
+              </a:lnSpc>
+              <a:buNone/>
+            </a:pPr>
+            <a:r>
+              <a:rPr lang="en-US" sz="950" dirty="0">
                 <a:solidFill>
                   <a:srgbClr val="C2C8D2"/>
                 </a:solidFill>
@@ -14642,758 +15187,9 @@
                 <a:ea typeface="Arial" pitchFamily="34" charset="-122"/>
                 <a:cs typeface="Arial" pitchFamily="34" charset="-120"/>
               </a:rPr>
-              <a:t>WERKPERIODE</a:t>
-            </a:r>
-            <a:endParaRPr lang="en-US" sz="800" dirty="0"/>
-          </a:p>
-        </p:txBody>
-      </p:sp>
-      <p:sp>
-        <p:nvSpPr>
-          <p:cNvPr id="9" name="Text 7"/>
-          <p:cNvSpPr txBox="1"/>
-          <p:nvPr/>
-        </p:nvSpPr>
-        <p:spPr>
-          <a:xfrm>
-            <a:off x="3886190" y="2666993"/>
-            <a:ext cx="2349494" cy="469899"/>
-          </a:xfrm>
-          <a:prstGeom prst="rect">
-            <a:avLst/>
-          </a:prstGeom>
-          <a:noFill/>
-          <a:ln/>
-        </p:spPr>
-        <p:txBody>
-          <a:bodyPr wrap="square" lIns="0" tIns="0" rIns="0" bIns="0" rtlCol="0" anchor="ctr"/>
-          <a:lstStyle/>
-          <a:p>
-            <a:pPr indent="0" marL="0">
-              <a:buNone/>
-            </a:pPr>
-            <a:r>
-              <a:rPr lang="en-US" sz="800" b="1" spc="160" kern="0" dirty="0">
-                <a:solidFill>
-                  <a:srgbClr val="C2C8D2"/>
-                </a:solidFill>
-                <a:latin typeface="Arial" pitchFamily="34" charset="0"/>
-                <a:ea typeface="Arial" pitchFamily="34" charset="-122"/>
-                <a:cs typeface="Arial" pitchFamily="34" charset="-120"/>
-              </a:rPr>
-              <a:t>CONTACTPOGINGEN</a:t>
-            </a:r>
-            <a:endParaRPr lang="en-US" sz="800" dirty="0"/>
-          </a:p>
-        </p:txBody>
-      </p:sp>
-      <p:sp>
-        <p:nvSpPr>
-          <p:cNvPr id="10" name="Text 8"/>
-          <p:cNvSpPr txBox="1"/>
-          <p:nvPr/>
-        </p:nvSpPr>
-        <p:spPr>
-          <a:xfrm>
-            <a:off x="6324584" y="2666993"/>
-            <a:ext cx="2349494" cy="469899"/>
-          </a:xfrm>
-          <a:prstGeom prst="rect">
-            <a:avLst/>
-          </a:prstGeom>
-          <a:noFill/>
-          <a:ln/>
-        </p:spPr>
-        <p:txBody>
-          <a:bodyPr wrap="square" lIns="0" tIns="0" rIns="0" bIns="0" rtlCol="0" anchor="ctr"/>
-          <a:lstStyle/>
-          <a:p>
-            <a:pPr indent="0" marL="0">
-              <a:buNone/>
-            </a:pPr>
-            <a:r>
-              <a:rPr lang="en-US" sz="800" b="1" spc="160" kern="0" dirty="0">
-                <a:solidFill>
-                  <a:srgbClr val="C2C8D2"/>
-                </a:solidFill>
-                <a:latin typeface="Arial" pitchFamily="34" charset="0"/>
-                <a:ea typeface="Arial" pitchFamily="34" charset="-122"/>
-                <a:cs typeface="Arial" pitchFamily="34" charset="-120"/>
-              </a:rPr>
-              <a:t>AFSPRAKEN</a:t>
-            </a:r>
-            <a:endParaRPr lang="en-US" sz="800" dirty="0"/>
-          </a:p>
-        </p:txBody>
-      </p:sp>
-      <p:sp>
-        <p:nvSpPr>
-          <p:cNvPr id="11" name="Text 9"/>
-          <p:cNvSpPr txBox="1"/>
-          <p:nvPr/>
-        </p:nvSpPr>
-        <p:spPr>
-          <a:xfrm>
-            <a:off x="8737578" y="2666993"/>
-            <a:ext cx="2539994" cy="469899"/>
-          </a:xfrm>
-          <a:prstGeom prst="rect">
-            <a:avLst/>
-          </a:prstGeom>
-          <a:noFill/>
-          <a:ln/>
-        </p:spPr>
-        <p:txBody>
-          <a:bodyPr wrap="square" lIns="0" tIns="0" rIns="0" bIns="0" rtlCol="0" anchor="ctr"/>
-          <a:lstStyle/>
-          <a:p>
-            <a:pPr indent="0" marL="0">
-              <a:buNone/>
-            </a:pPr>
-            <a:r>
-              <a:rPr lang="en-US" sz="800" b="1" spc="160" kern="0" dirty="0">
-                <a:solidFill>
-                  <a:srgbClr val="C2C8D2"/>
-                </a:solidFill>
-                <a:latin typeface="Arial" pitchFamily="34" charset="0"/>
-                <a:ea typeface="Arial" pitchFamily="34" charset="-122"/>
-                <a:cs typeface="Arial" pitchFamily="34" charset="-120"/>
-              </a:rPr>
-              <a:t>PER 1.000 POGINGEN</a:t>
-            </a:r>
-            <a:endParaRPr lang="en-US" sz="800" dirty="0"/>
-          </a:p>
-        </p:txBody>
-      </p:sp>
-      <p:sp>
-        <p:nvSpPr>
-          <p:cNvPr id="12" name="Shape 10"/>
-          <p:cNvSpPr/>
-          <p:nvPr/>
-        </p:nvSpPr>
-        <p:spPr>
-          <a:xfrm>
-            <a:off x="609598" y="3136892"/>
-            <a:ext cx="10972773" cy="0"/>
-          </a:xfrm>
-          <a:prstGeom prst="line">
-            <a:avLst/>
-          </a:prstGeom>
-          <a:noFill/>
-          <a:ln w="9525">
-            <a:solidFill>
-              <a:srgbClr val="3A4152"/>
-            </a:solidFill>
-            <a:prstDash val="solid"/>
-          </a:ln>
-        </p:spPr>
-      </p:sp>
-      <p:sp>
-        <p:nvSpPr>
-          <p:cNvPr id="13" name="Text 11"/>
-          <p:cNvSpPr txBox="1"/>
-          <p:nvPr/>
-        </p:nvSpPr>
-        <p:spPr>
-          <a:xfrm>
-            <a:off x="888998" y="3136892"/>
-            <a:ext cx="2920993" cy="628648"/>
-          </a:xfrm>
-          <a:prstGeom prst="rect">
-            <a:avLst/>
-          </a:prstGeom>
-          <a:noFill/>
-          <a:ln/>
-        </p:spPr>
-        <p:txBody>
-          <a:bodyPr wrap="square" lIns="0" tIns="0" rIns="0" bIns="0" rtlCol="0" anchor="ctr"/>
-          <a:lstStyle/>
-          <a:p>
-            <a:pPr indent="0" marL="0">
-              <a:buNone/>
-            </a:pPr>
-            <a:r>
-              <a:rPr lang="en-US" sz="1250" b="1" dirty="0">
-                <a:solidFill>
-                  <a:srgbClr val="F2EFE6"/>
-                </a:solidFill>
-                <a:latin typeface="Arial" pitchFamily="34" charset="0"/>
-                <a:ea typeface="Arial" pitchFamily="34" charset="-122"/>
-                <a:cs typeface="Arial" pitchFamily="34" charset="-120"/>
-              </a:rPr>
-              <a:t>1 · 3 t/m 30 augustus</a:t>
-            </a:r>
-            <a:endParaRPr lang="en-US" sz="1250" dirty="0"/>
-          </a:p>
-        </p:txBody>
-      </p:sp>
-      <p:sp>
-        <p:nvSpPr>
-          <p:cNvPr id="14" name="Text 12"/>
-          <p:cNvSpPr txBox="1"/>
-          <p:nvPr/>
-        </p:nvSpPr>
-        <p:spPr>
-          <a:xfrm>
-            <a:off x="3886190" y="3136892"/>
-            <a:ext cx="2349494" cy="628648"/>
-          </a:xfrm>
-          <a:prstGeom prst="rect">
-            <a:avLst/>
-          </a:prstGeom>
-          <a:noFill/>
-          <a:ln/>
-        </p:spPr>
-        <p:txBody>
-          <a:bodyPr wrap="square" lIns="0" tIns="0" rIns="0" bIns="0" rtlCol="0" anchor="ctr"/>
-          <a:lstStyle/>
-          <a:p>
-            <a:pPr indent="0" marL="0">
-              <a:buNone/>
-            </a:pPr>
-            <a:r>
-              <a:rPr lang="en-US" sz="1250" b="1" dirty="0">
-                <a:solidFill>
-                  <a:srgbClr val="F2EFE6"/>
-                </a:solidFill>
-                <a:latin typeface="Arial" pitchFamily="34" charset="0"/>
-                <a:ea typeface="Arial" pitchFamily="34" charset="-122"/>
-                <a:cs typeface="Arial" pitchFamily="34" charset="-120"/>
-              </a:rPr>
-              <a:t>192</a:t>
-            </a:r>
-            <a:endParaRPr lang="en-US" sz="1250" dirty="0"/>
-          </a:p>
-        </p:txBody>
-      </p:sp>
-      <p:sp>
-        <p:nvSpPr>
-          <p:cNvPr id="15" name="Text 13"/>
-          <p:cNvSpPr txBox="1"/>
-          <p:nvPr/>
-        </p:nvSpPr>
-        <p:spPr>
-          <a:xfrm>
-            <a:off x="6324584" y="3136892"/>
-            <a:ext cx="2349494" cy="628648"/>
-          </a:xfrm>
-          <a:prstGeom prst="rect">
-            <a:avLst/>
-          </a:prstGeom>
-          <a:noFill/>
-          <a:ln/>
-        </p:spPr>
-        <p:txBody>
-          <a:bodyPr wrap="square" lIns="0" tIns="0" rIns="0" bIns="0" rtlCol="0" anchor="ctr"/>
-          <a:lstStyle/>
-          <a:p>
-            <a:pPr indent="0" marL="0">
-              <a:buNone/>
-            </a:pPr>
-            <a:r>
-              <a:rPr lang="en-US" sz="1250" b="1" dirty="0">
-                <a:solidFill>
-                  <a:srgbClr val="F2EFE6"/>
-                </a:solidFill>
-                <a:latin typeface="Arial" pitchFamily="34" charset="0"/>
-                <a:ea typeface="Arial" pitchFamily="34" charset="-122"/>
-                <a:cs typeface="Arial" pitchFamily="34" charset="-120"/>
-              </a:rPr>
-              <a:t>5</a:t>
-            </a:r>
-            <a:endParaRPr lang="en-US" sz="1250" dirty="0"/>
-          </a:p>
-        </p:txBody>
-      </p:sp>
-      <p:sp>
-        <p:nvSpPr>
-          <p:cNvPr id="16" name="Text 14"/>
-          <p:cNvSpPr txBox="1"/>
-          <p:nvPr/>
-        </p:nvSpPr>
-        <p:spPr>
-          <a:xfrm>
-            <a:off x="8737578" y="3136892"/>
-            <a:ext cx="2539994" cy="628648"/>
-          </a:xfrm>
-          <a:prstGeom prst="rect">
-            <a:avLst/>
-          </a:prstGeom>
-          <a:noFill/>
-          <a:ln/>
-        </p:spPr>
-        <p:txBody>
-          <a:bodyPr wrap="square" lIns="0" tIns="0" rIns="0" bIns="0" rtlCol="0" anchor="ctr"/>
-          <a:lstStyle/>
-          <a:p>
-            <a:pPr indent="0" marL="0">
-              <a:buNone/>
-            </a:pPr>
-            <a:r>
-              <a:rPr lang="en-US" sz="1250" b="1" dirty="0">
-                <a:solidFill>
-                  <a:srgbClr val="F2EFE6"/>
-                </a:solidFill>
-                <a:latin typeface="Arial" pitchFamily="34" charset="0"/>
-                <a:ea typeface="Arial" pitchFamily="34" charset="-122"/>
-                <a:cs typeface="Arial" pitchFamily="34" charset="-120"/>
-              </a:rPr>
-              <a:t>26</a:t>
-            </a:r>
-            <a:endParaRPr lang="en-US" sz="1250" dirty="0"/>
-          </a:p>
-        </p:txBody>
-      </p:sp>
-      <p:sp>
-        <p:nvSpPr>
-          <p:cNvPr id="17" name="Shape 15"/>
-          <p:cNvSpPr/>
-          <p:nvPr/>
-        </p:nvSpPr>
-        <p:spPr>
-          <a:xfrm>
-            <a:off x="609598" y="3765541"/>
-            <a:ext cx="10972773" cy="0"/>
-          </a:xfrm>
-          <a:prstGeom prst="line">
-            <a:avLst/>
-          </a:prstGeom>
-          <a:noFill/>
-          <a:ln w="9525">
-            <a:solidFill>
-              <a:srgbClr val="3A4152"/>
-            </a:solidFill>
-            <a:prstDash val="solid"/>
-          </a:ln>
-        </p:spPr>
-      </p:sp>
-      <p:sp>
-        <p:nvSpPr>
-          <p:cNvPr id="18" name="Text 16"/>
-          <p:cNvSpPr txBox="1"/>
-          <p:nvPr/>
-        </p:nvSpPr>
-        <p:spPr>
-          <a:xfrm>
-            <a:off x="888998" y="3765541"/>
-            <a:ext cx="2920993" cy="628648"/>
-          </a:xfrm>
-          <a:prstGeom prst="rect">
-            <a:avLst/>
-          </a:prstGeom>
-          <a:noFill/>
-          <a:ln/>
-        </p:spPr>
-        <p:txBody>
-          <a:bodyPr wrap="square" lIns="0" tIns="0" rIns="0" bIns="0" rtlCol="0" anchor="ctr"/>
-          <a:lstStyle/>
-          <a:p>
-            <a:pPr indent="0" marL="0">
-              <a:buNone/>
-            </a:pPr>
-            <a:r>
-              <a:rPr lang="en-US" sz="1250" b="1" dirty="0">
-                <a:solidFill>
-                  <a:srgbClr val="F2EFE6"/>
-                </a:solidFill>
-                <a:latin typeface="Arial" pitchFamily="34" charset="0"/>
-                <a:ea typeface="Arial" pitchFamily="34" charset="-122"/>
-                <a:cs typeface="Arial" pitchFamily="34" charset="-120"/>
-              </a:rPr>
-              <a:t>2 · 31 aug t/m 27 september</a:t>
-            </a:r>
-            <a:endParaRPr lang="en-US" sz="1250" dirty="0"/>
-          </a:p>
-        </p:txBody>
-      </p:sp>
-      <p:sp>
-        <p:nvSpPr>
-          <p:cNvPr id="19" name="Text 17"/>
-          <p:cNvSpPr txBox="1"/>
-          <p:nvPr/>
-        </p:nvSpPr>
-        <p:spPr>
-          <a:xfrm>
-            <a:off x="3886190" y="3765541"/>
-            <a:ext cx="2349494" cy="628648"/>
-          </a:xfrm>
-          <a:prstGeom prst="rect">
-            <a:avLst/>
-          </a:prstGeom>
-          <a:noFill/>
-          <a:ln/>
-        </p:spPr>
-        <p:txBody>
-          <a:bodyPr wrap="square" lIns="0" tIns="0" rIns="0" bIns="0" rtlCol="0" anchor="ctr"/>
-          <a:lstStyle/>
-          <a:p>
-            <a:pPr indent="0" marL="0">
-              <a:buNone/>
-            </a:pPr>
-            <a:r>
-              <a:rPr lang="en-US" sz="1250" b="1" dirty="0">
-                <a:solidFill>
-                  <a:srgbClr val="F2EFE6"/>
-                </a:solidFill>
-                <a:latin typeface="Arial" pitchFamily="34" charset="0"/>
-                <a:ea typeface="Arial" pitchFamily="34" charset="-122"/>
-                <a:cs typeface="Arial" pitchFamily="34" charset="-120"/>
-              </a:rPr>
-              <a:t>631</a:t>
-            </a:r>
-            <a:endParaRPr lang="en-US" sz="1250" dirty="0"/>
-          </a:p>
-        </p:txBody>
-      </p:sp>
-      <p:sp>
-        <p:nvSpPr>
-          <p:cNvPr id="20" name="Text 18"/>
-          <p:cNvSpPr txBox="1"/>
-          <p:nvPr/>
-        </p:nvSpPr>
-        <p:spPr>
-          <a:xfrm>
-            <a:off x="6324584" y="3765541"/>
-            <a:ext cx="2349494" cy="628648"/>
-          </a:xfrm>
-          <a:prstGeom prst="rect">
-            <a:avLst/>
-          </a:prstGeom>
-          <a:noFill/>
-          <a:ln/>
-        </p:spPr>
-        <p:txBody>
-          <a:bodyPr wrap="square" lIns="0" tIns="0" rIns="0" bIns="0" rtlCol="0" anchor="ctr"/>
-          <a:lstStyle/>
-          <a:p>
-            <a:pPr indent="0" marL="0">
-              <a:buNone/>
-            </a:pPr>
-            <a:r>
-              <a:rPr lang="en-US" sz="1250" b="1" dirty="0">
-                <a:solidFill>
-                  <a:srgbClr val="F2EFE6"/>
-                </a:solidFill>
-                <a:latin typeface="Arial" pitchFamily="34" charset="0"/>
-                <a:ea typeface="Arial" pitchFamily="34" charset="-122"/>
-                <a:cs typeface="Arial" pitchFamily="34" charset="-120"/>
-              </a:rPr>
-              <a:t>3</a:t>
-            </a:r>
-            <a:endParaRPr lang="en-US" sz="1250" dirty="0"/>
-          </a:p>
-        </p:txBody>
-      </p:sp>
-      <p:sp>
-        <p:nvSpPr>
-          <p:cNvPr id="21" name="Text 19"/>
-          <p:cNvSpPr txBox="1"/>
-          <p:nvPr/>
-        </p:nvSpPr>
-        <p:spPr>
-          <a:xfrm>
-            <a:off x="8737578" y="3765541"/>
-            <a:ext cx="2539994" cy="628648"/>
-          </a:xfrm>
-          <a:prstGeom prst="rect">
-            <a:avLst/>
-          </a:prstGeom>
-          <a:noFill/>
-          <a:ln/>
-        </p:spPr>
-        <p:txBody>
-          <a:bodyPr wrap="square" lIns="0" tIns="0" rIns="0" bIns="0" rtlCol="0" anchor="ctr"/>
-          <a:lstStyle/>
-          <a:p>
-            <a:pPr indent="0" marL="0">
-              <a:buNone/>
-            </a:pPr>
-            <a:r>
-              <a:rPr lang="en-US" sz="1250" b="1" dirty="0">
-                <a:solidFill>
-                  <a:srgbClr val="F2EFE6"/>
-                </a:solidFill>
-                <a:latin typeface="Arial" pitchFamily="34" charset="0"/>
-                <a:ea typeface="Arial" pitchFamily="34" charset="-122"/>
-                <a:cs typeface="Arial" pitchFamily="34" charset="-120"/>
-              </a:rPr>
-              <a:t>5</a:t>
-            </a:r>
-            <a:endParaRPr lang="en-US" sz="1250" dirty="0"/>
-          </a:p>
-        </p:txBody>
-      </p:sp>
-      <p:sp>
-        <p:nvSpPr>
-          <p:cNvPr id="22" name="Shape 20"/>
-          <p:cNvSpPr/>
-          <p:nvPr/>
-        </p:nvSpPr>
-        <p:spPr>
-          <a:xfrm>
-            <a:off x="615948" y="4394189"/>
-            <a:ext cx="10960073" cy="628648"/>
-          </a:xfrm>
-          <a:prstGeom prst="rect">
-            <a:avLst/>
-          </a:prstGeom>
-          <a:solidFill>
-            <a:srgbClr val="38B6FF">
-              <a:alpha val="11000"/>
-            </a:srgbClr>
-          </a:solidFill>
-          <a:ln/>
-        </p:spPr>
-      </p:sp>
-      <p:sp>
-        <p:nvSpPr>
-          <p:cNvPr id="23" name="Shape 21"/>
-          <p:cNvSpPr/>
-          <p:nvPr/>
-        </p:nvSpPr>
-        <p:spPr>
-          <a:xfrm>
-            <a:off x="609598" y="4394189"/>
-            <a:ext cx="10972773" cy="0"/>
-          </a:xfrm>
-          <a:prstGeom prst="line">
-            <a:avLst/>
-          </a:prstGeom>
-          <a:noFill/>
-          <a:ln w="9525">
-            <a:solidFill>
-              <a:srgbClr val="3A4152"/>
-            </a:solidFill>
-            <a:prstDash val="solid"/>
-          </a:ln>
-        </p:spPr>
-      </p:sp>
-      <p:sp>
-        <p:nvSpPr>
-          <p:cNvPr id="24" name="Text 22"/>
-          <p:cNvSpPr txBox="1"/>
-          <p:nvPr/>
-        </p:nvSpPr>
-        <p:spPr>
-          <a:xfrm>
-            <a:off x="888998" y="4394189"/>
-            <a:ext cx="2920993" cy="628648"/>
-          </a:xfrm>
-          <a:prstGeom prst="rect">
-            <a:avLst/>
-          </a:prstGeom>
-          <a:noFill/>
-          <a:ln/>
-        </p:spPr>
-        <p:txBody>
-          <a:bodyPr wrap="square" lIns="0" tIns="0" rIns="0" bIns="0" rtlCol="0" anchor="ctr"/>
-          <a:lstStyle/>
-          <a:p>
-            <a:pPr indent="0" marL="0">
-              <a:buNone/>
-            </a:pPr>
-            <a:r>
-              <a:rPr lang="en-US" sz="1250" b="1" dirty="0">
-                <a:solidFill>
-                  <a:srgbClr val="F2EFE6"/>
-                </a:solidFill>
-                <a:latin typeface="Arial" pitchFamily="34" charset="0"/>
-                <a:ea typeface="Arial" pitchFamily="34" charset="-122"/>
-                <a:cs typeface="Arial" pitchFamily="34" charset="-120"/>
-              </a:rPr>
-              <a:t>3 · 28 sep t/m 25 oktober</a:t>
-            </a:r>
-            <a:pPr indent="0" marL="0">
-              <a:buNone/>
-            </a:pPr>
-            <a:r>
-              <a:rPr lang="en-US" sz="1000" i="1" dirty="0">
-                <a:solidFill>
-                  <a:srgbClr val="38B6FF"/>
-                </a:solidFill>
-                <a:latin typeface="Georgia" pitchFamily="34" charset="0"/>
-                <a:ea typeface="Georgia" pitchFamily="34" charset="-122"/>
-                <a:cs typeface="Georgia" pitchFamily="34" charset="-120"/>
-              </a:rPr>
-              <a:t>   loopt nog</a:t>
-            </a:r>
-            <a:endParaRPr lang="en-US" sz="1250" dirty="0"/>
-          </a:p>
-        </p:txBody>
-      </p:sp>
-      <p:sp>
-        <p:nvSpPr>
-          <p:cNvPr id="25" name="Text 23"/>
-          <p:cNvSpPr txBox="1"/>
-          <p:nvPr/>
-        </p:nvSpPr>
-        <p:spPr>
-          <a:xfrm>
-            <a:off x="3886190" y="4394189"/>
-            <a:ext cx="2349494" cy="628648"/>
-          </a:xfrm>
-          <a:prstGeom prst="rect">
-            <a:avLst/>
-          </a:prstGeom>
-          <a:noFill/>
-          <a:ln/>
-        </p:spPr>
-        <p:txBody>
-          <a:bodyPr wrap="square" lIns="0" tIns="0" rIns="0" bIns="0" rtlCol="0" anchor="ctr"/>
-          <a:lstStyle/>
-          <a:p>
-            <a:pPr indent="0" marL="0">
-              <a:buNone/>
-            </a:pPr>
-            <a:r>
-              <a:rPr lang="en-US" sz="1250" b="1" dirty="0">
-                <a:solidFill>
-                  <a:srgbClr val="F2EFE6"/>
-                </a:solidFill>
-                <a:latin typeface="Arial" pitchFamily="34" charset="0"/>
-                <a:ea typeface="Arial" pitchFamily="34" charset="-122"/>
-                <a:cs typeface="Arial" pitchFamily="34" charset="-120"/>
-              </a:rPr>
-              <a:t>837</a:t>
-            </a:r>
-            <a:endParaRPr lang="en-US" sz="1250" dirty="0"/>
-          </a:p>
-        </p:txBody>
-      </p:sp>
-      <p:sp>
-        <p:nvSpPr>
-          <p:cNvPr id="26" name="Text 24"/>
-          <p:cNvSpPr txBox="1"/>
-          <p:nvPr/>
-        </p:nvSpPr>
-        <p:spPr>
-          <a:xfrm>
-            <a:off x="6324584" y="4394189"/>
-            <a:ext cx="2349494" cy="628648"/>
-          </a:xfrm>
-          <a:prstGeom prst="rect">
-            <a:avLst/>
-          </a:prstGeom>
-          <a:noFill/>
-          <a:ln/>
-        </p:spPr>
-        <p:txBody>
-          <a:bodyPr wrap="square" lIns="0" tIns="0" rIns="0" bIns="0" rtlCol="0" anchor="ctr"/>
-          <a:lstStyle/>
-          <a:p>
-            <a:pPr indent="0" marL="0">
-              <a:buNone/>
-            </a:pPr>
-            <a:r>
-              <a:rPr lang="en-US" sz="1250" b="1" dirty="0">
-                <a:solidFill>
-                  <a:srgbClr val="F2EFE6"/>
-                </a:solidFill>
-                <a:latin typeface="Arial" pitchFamily="34" charset="0"/>
-                <a:ea typeface="Arial" pitchFamily="34" charset="-122"/>
-                <a:cs typeface="Arial" pitchFamily="34" charset="-120"/>
-              </a:rPr>
-              <a:t>4</a:t>
-            </a:r>
-            <a:endParaRPr lang="en-US" sz="1250" dirty="0"/>
-          </a:p>
-        </p:txBody>
-      </p:sp>
-      <p:sp>
-        <p:nvSpPr>
-          <p:cNvPr id="27" name="Text 25"/>
-          <p:cNvSpPr txBox="1"/>
-          <p:nvPr/>
-        </p:nvSpPr>
-        <p:spPr>
-          <a:xfrm>
-            <a:off x="8737578" y="4394189"/>
-            <a:ext cx="2539994" cy="628648"/>
-          </a:xfrm>
-          <a:prstGeom prst="rect">
-            <a:avLst/>
-          </a:prstGeom>
-          <a:noFill/>
-          <a:ln/>
-        </p:spPr>
-        <p:txBody>
-          <a:bodyPr wrap="square" lIns="0" tIns="0" rIns="0" bIns="0" rtlCol="0" anchor="ctr"/>
-          <a:lstStyle/>
-          <a:p>
-            <a:pPr indent="0" marL="0">
-              <a:buNone/>
-            </a:pPr>
-            <a:r>
-              <a:rPr lang="en-US" sz="1250" b="1" dirty="0">
-                <a:solidFill>
-                  <a:srgbClr val="F2EFE6"/>
-                </a:solidFill>
-                <a:latin typeface="Arial" pitchFamily="34" charset="0"/>
-                <a:ea typeface="Arial" pitchFamily="34" charset="-122"/>
-                <a:cs typeface="Arial" pitchFamily="34" charset="-120"/>
-              </a:rPr>
-              <a:t>5</a:t>
-            </a:r>
-            <a:endParaRPr lang="en-US" sz="1250" dirty="0"/>
-          </a:p>
-        </p:txBody>
-      </p:sp>
-      <p:sp>
-        <p:nvSpPr>
-          <p:cNvPr id="28" name="Shape 26"/>
-          <p:cNvSpPr/>
-          <p:nvPr/>
-        </p:nvSpPr>
-        <p:spPr>
-          <a:xfrm>
-            <a:off x="609598" y="5854685"/>
-            <a:ext cx="76200" cy="76200"/>
-          </a:xfrm>
-          <a:prstGeom prst="ellipse">
-            <a:avLst/>
-          </a:prstGeom>
-          <a:solidFill>
-            <a:srgbClr val="38B6FF"/>
-          </a:solidFill>
-          <a:ln/>
-        </p:spPr>
-      </p:sp>
-      <p:sp>
-        <p:nvSpPr>
-          <p:cNvPr id="29" name="Text 27"/>
-          <p:cNvSpPr txBox="1"/>
-          <p:nvPr/>
-        </p:nvSpPr>
-        <p:spPr>
-          <a:xfrm>
-            <a:off x="800098" y="5651486"/>
-            <a:ext cx="9905975" cy="482599"/>
-          </a:xfrm>
-          <a:prstGeom prst="rect">
-            <a:avLst/>
-          </a:prstGeom>
-          <a:noFill/>
-          <a:ln/>
-        </p:spPr>
-        <p:txBody>
-          <a:bodyPr wrap="square" lIns="0" tIns="0" rIns="0" bIns="0" rtlCol="0" anchor="ctr"/>
-          <a:lstStyle/>
-          <a:p>
-            <a:pPr indent="0" marL="0">
-              <a:buNone/>
-            </a:pPr>
-            <a:r>
-              <a:rPr lang="en-US" sz="1200" b="1" dirty="0">
-                <a:solidFill>
-                  <a:srgbClr val="F2EFE6"/>
-                </a:solidFill>
-                <a:latin typeface="Arial" pitchFamily="34" charset="0"/>
-                <a:ea typeface="Arial" pitchFamily="34" charset="-122"/>
-                <a:cs typeface="Arial" pitchFamily="34" charset="-120"/>
-              </a:rPr>
-              <a:t>Werkperiode 1 was klein: 200 pogingen. Daarna ging het volume fors omhoog en werd de lijst tegelijk kouder. Dat verklaart het verschil in rendement en het wijst precies aan welke knop vanaf werkperiode 4 omhoog moet.</a:t>
-            </a:r>
-            <a:endParaRPr lang="en-US" sz="1200" dirty="0"/>
+              <a:t>Verpact, Zorgwerk, Hotel Specials, Doen'r, Aluwdoors, AAme, BNU Personeel, Rotterdam Leisure Group en TC Productions.</a:t>
+            </a:r>
+            <a:endParaRPr lang="en-US" sz="950" dirty="0"/>
           </a:p>
         </p:txBody>
       </p:sp>
@@ -15411,7 +15207,7 @@
     <p:bg>
       <p:bgPr>
         <a:solidFill>
-          <a:srgbClr val="141821"/>
+          <a:srgbClr val="E9E0CD"/>
         </a:solidFill>
       </p:bgPr>
     </p:bg>
@@ -15456,7 +15252,7 @@
             <a:r>
               <a:rPr lang="en-US" sz="1800" b="1" dirty="0">
                 <a:solidFill>
-                  <a:srgbClr val="F2EFE6"/>
+                  <a:srgbClr val="1C2230"/>
                 </a:solidFill>
                 <a:latin typeface="Arial" pitchFamily="34" charset="0"/>
                 <a:ea typeface="Arial" pitchFamily="34" charset="-122"/>
@@ -15509,7 +15305,7 @@
             <a:r>
               <a:rPr lang="en-US" sz="750" b="1" spc="100" kern="0" dirty="0">
                 <a:solidFill>
-                  <a:srgbClr val="BDC3CE"/>
+                  <a:srgbClr val="6F6A5C"/>
                 </a:solidFill>
                 <a:latin typeface="Arial" pitchFamily="34" charset="0"/>
                 <a:ea typeface="Arial" pitchFamily="34" charset="-122"/>
@@ -15548,7 +15344,7 @@
             <a:r>
               <a:rPr lang="en-US" sz="750" b="1" spc="100" kern="0" dirty="0">
                 <a:solidFill>
-                  <a:srgbClr val="BDC3CE"/>
+                  <a:srgbClr val="6F6A5C"/>
                 </a:solidFill>
                 <a:latin typeface="Arial" pitchFamily="34" charset="0"/>
                 <a:ea typeface="Arial" pitchFamily="34" charset="-122"/>
@@ -15593,7 +15389,7 @@
                 <a:ea typeface="Arial" pitchFamily="34" charset="-122"/>
                 <a:cs typeface="Arial" pitchFamily="34" charset="-120"/>
               </a:rPr>
-              <a:t>WAAR HET VERSCHIL ZIT</a:t>
+              <a:t>WAT ER KLAARSTAAT</a:t>
             </a:r>
             <a:endParaRPr lang="en-US" sz="950" dirty="0"/>
           </a:p>
@@ -15629,13 +15425,13 @@
             <a:r>
               <a:rPr lang="en-US" sz="3200" b="1" dirty="0">
                 <a:solidFill>
-                  <a:srgbClr val="F2EFE6"/>
-                </a:solidFill>
-                <a:latin typeface="Arial" pitchFamily="34" charset="0"/>
-                <a:ea typeface="Arial" pitchFamily="34" charset="-122"/>
-                <a:cs typeface="Arial" pitchFamily="34" charset="-120"/>
-              </a:rPr>
-              <a:t>De lijst met jullie eigen relaties loopt </a:t>
+                  <a:srgbClr val="1C2230"/>
+                </a:solidFill>
+                <a:latin typeface="Arial" pitchFamily="34" charset="0"/>
+                <a:ea typeface="Arial" pitchFamily="34" charset="-122"/>
+                <a:cs typeface="Arial" pitchFamily="34" charset="-120"/>
+              </a:rPr>
+              <a:t>Zestig bedrijven wachten op </a:t>
             </a:r>
             <a:pPr algn="l" indent="0" marL="0">
               <a:lnSpc>
@@ -15646,13 +15442,13 @@
             <a:r>
               <a:rPr lang="en-US" sz="3000" i="1" dirty="0">
                 <a:solidFill>
-                  <a:srgbClr val="F2EFE6"/>
+                  <a:srgbClr val="1C2230"/>
                 </a:solidFill>
                 <a:latin typeface="Georgia" pitchFamily="34" charset="0"/>
                 <a:ea typeface="Georgia" pitchFamily="34" charset="-122"/>
                 <a:cs typeface="Georgia" pitchFamily="34" charset="-120"/>
               </a:rPr>
-              <a:t>drie keer beter</a:t>
+              <a:t>een tweede belletje</a:t>
             </a:r>
             <a:pPr algn="l" indent="0" marL="0">
               <a:lnSpc>
@@ -15663,7 +15459,7 @@
             <a:r>
               <a:rPr lang="en-US" sz="3200" b="1" dirty="0">
                 <a:solidFill>
-                  <a:srgbClr val="F2EFE6"/>
+                  <a:srgbClr val="1C2230"/>
                 </a:solidFill>
                 <a:latin typeface="Arial" pitchFamily="34" charset="0"/>
                 <a:ea typeface="Arial" pitchFamily="34" charset="-122"/>
@@ -15683,20 +15479,18 @@
         </p:nvSpPr>
         <p:spPr>
           <a:xfrm>
-            <a:off x="609598" y="2666993"/>
-            <a:ext cx="10972773" cy="2355844"/>
+            <a:off x="609598" y="2730493"/>
+            <a:ext cx="2628893" cy="2222494"/>
           </a:xfrm>
           <a:prstGeom prst="roundRect">
             <a:avLst>
-              <a:gd name="adj" fmla="val 4313"/>
+              <a:gd name="adj" fmla="val 4571"/>
             </a:avLst>
           </a:prstGeom>
-          <a:ln w="9525">
-            <a:solidFill>
-              <a:srgbClr val="3A4152"/>
-            </a:solidFill>
-            <a:prstDash val="solid"/>
-          </a:ln>
+          <a:solidFill>
+            <a:srgbClr val="F8F4EB"/>
+          </a:solidFill>
+          <a:ln/>
         </p:spPr>
       </p:sp>
       <p:sp>
@@ -15707,8 +15501,8 @@
         </p:nvSpPr>
         <p:spPr>
           <a:xfrm>
-            <a:off x="888998" y="2666993"/>
-            <a:ext cx="2920993" cy="469899"/>
+            <a:off x="850898" y="2997193"/>
+            <a:ext cx="2146295" cy="507999"/>
           </a:xfrm>
           <a:prstGeom prst="rect">
             <a:avLst/>
@@ -15724,7 +15518,514 @@
               <a:buNone/>
             </a:pPr>
             <a:r>
-              <a:rPr lang="en-US" sz="800" b="1" spc="160" kern="0" dirty="0">
+              <a:rPr lang="en-US" sz="3600" b="1" dirty="0">
+                <a:solidFill>
+                  <a:srgbClr val="1C2230"/>
+                </a:solidFill>
+                <a:latin typeface="Arial" pitchFamily="34" charset="0"/>
+                <a:ea typeface="Arial" pitchFamily="34" charset="-122"/>
+                <a:cs typeface="Arial" pitchFamily="34" charset="-120"/>
+              </a:rPr>
+              <a:t>90</a:t>
+            </a:r>
+            <a:endParaRPr lang="en-US" sz="3600" dirty="0"/>
+          </a:p>
+        </p:txBody>
+      </p:sp>
+      <p:sp>
+        <p:nvSpPr>
+          <p:cNvPr id="9" name="Text 7"/>
+          <p:cNvSpPr txBox="1"/>
+          <p:nvPr/>
+        </p:nvSpPr>
+        <p:spPr>
+          <a:xfrm>
+            <a:off x="850898" y="3555991"/>
+            <a:ext cx="2146295" cy="215899"/>
+          </a:xfrm>
+          <a:prstGeom prst="rect">
+            <a:avLst/>
+          </a:prstGeom>
+          <a:noFill/>
+          <a:ln/>
+        </p:spPr>
+        <p:txBody>
+          <a:bodyPr wrap="square" lIns="0" tIns="0" rIns="0" bIns="0" rtlCol="0" anchor="ctr"/>
+          <a:lstStyle/>
+          <a:p>
+            <a:pPr indent="0" marL="0">
+              <a:buNone/>
+            </a:pPr>
+            <a:r>
+              <a:rPr lang="en-US" sz="900" b="1" spc="120" kern="0" dirty="0">
+                <a:solidFill>
+                  <a:srgbClr val="38B6FF"/>
+                </a:solidFill>
+                <a:latin typeface="Arial" pitchFamily="34" charset="0"/>
+                <a:ea typeface="Arial" pitchFamily="34" charset="-122"/>
+                <a:cs typeface="Arial" pitchFamily="34" charset="-120"/>
+              </a:rPr>
+              <a:t>TERUGBELAFSPRAKEN</a:t>
+            </a:r>
+            <a:endParaRPr lang="en-US" sz="900" dirty="0"/>
+          </a:p>
+        </p:txBody>
+      </p:sp>
+      <p:sp>
+        <p:nvSpPr>
+          <p:cNvPr id="10" name="Text 8"/>
+          <p:cNvSpPr txBox="1"/>
+          <p:nvPr/>
+        </p:nvSpPr>
+        <p:spPr>
+          <a:xfrm>
+            <a:off x="850898" y="3975090"/>
+            <a:ext cx="2146295" cy="888998"/>
+          </a:xfrm>
+          <a:prstGeom prst="rect">
+            <a:avLst/>
+          </a:prstGeom>
+          <a:noFill/>
+          <a:ln/>
+        </p:spPr>
+        <p:txBody>
+          <a:bodyPr wrap="square" lIns="0" tIns="0" rIns="0" bIns="0" rtlCol="0" anchor="t"/>
+          <a:lstStyle/>
+          <a:p>
+            <a:pPr indent="0" marL="0">
+              <a:lnSpc>
+                <a:spcPct val="135000"/>
+              </a:lnSpc>
+              <a:buNone/>
+            </a:pPr>
+            <a:r>
+              <a:rPr lang="en-US" sz="950" dirty="0">
+                <a:solidFill>
+                  <a:srgbClr val="6F6A5C"/>
+                </a:solidFill>
+                <a:latin typeface="Arial" pitchFamily="34" charset="0"/>
+                <a:ea typeface="Arial" pitchFamily="34" charset="-122"/>
+                <a:cs typeface="Arial" pitchFamily="34" charset="-120"/>
+              </a:rPr>
+              <a:t>Afgesproken met de juiste persoon, op een afgesproken moment.</a:t>
+            </a:r>
+            <a:endParaRPr lang="en-US" sz="950" dirty="0"/>
+          </a:p>
+        </p:txBody>
+      </p:sp>
+      <p:sp>
+        <p:nvSpPr>
+          <p:cNvPr id="11" name="Shape 9"/>
+          <p:cNvSpPr/>
+          <p:nvPr/>
+        </p:nvSpPr>
+        <p:spPr>
+          <a:xfrm>
+            <a:off x="3390892" y="2730493"/>
+            <a:ext cx="2628893" cy="2222494"/>
+          </a:xfrm>
+          <a:prstGeom prst="roundRect">
+            <a:avLst>
+              <a:gd name="adj" fmla="val 4571"/>
+            </a:avLst>
+          </a:prstGeom>
+          <a:solidFill>
+            <a:srgbClr val="F8F4EB"/>
+          </a:solidFill>
+          <a:ln/>
+        </p:spPr>
+      </p:sp>
+      <p:sp>
+        <p:nvSpPr>
+          <p:cNvPr id="12" name="Text 10"/>
+          <p:cNvSpPr txBox="1"/>
+          <p:nvPr/>
+        </p:nvSpPr>
+        <p:spPr>
+          <a:xfrm>
+            <a:off x="3632191" y="2997193"/>
+            <a:ext cx="2146295" cy="507999"/>
+          </a:xfrm>
+          <a:prstGeom prst="rect">
+            <a:avLst/>
+          </a:prstGeom>
+          <a:noFill/>
+          <a:ln/>
+        </p:spPr>
+        <p:txBody>
+          <a:bodyPr wrap="square" lIns="0" tIns="0" rIns="0" bIns="0" rtlCol="0" anchor="ctr"/>
+          <a:lstStyle/>
+          <a:p>
+            <a:pPr indent="0" marL="0">
+              <a:buNone/>
+            </a:pPr>
+            <a:r>
+              <a:rPr lang="en-US" sz="3600" b="1" dirty="0">
+                <a:solidFill>
+                  <a:srgbClr val="1C2230"/>
+                </a:solidFill>
+                <a:latin typeface="Arial" pitchFamily="34" charset="0"/>
+                <a:ea typeface="Arial" pitchFamily="34" charset="-122"/>
+                <a:cs typeface="Arial" pitchFamily="34" charset="-120"/>
+              </a:rPr>
+              <a:t>23</a:t>
+            </a:r>
+            <a:endParaRPr lang="en-US" sz="3600" dirty="0"/>
+          </a:p>
+        </p:txBody>
+      </p:sp>
+      <p:sp>
+        <p:nvSpPr>
+          <p:cNvPr id="13" name="Text 11"/>
+          <p:cNvSpPr txBox="1"/>
+          <p:nvPr/>
+        </p:nvSpPr>
+        <p:spPr>
+          <a:xfrm>
+            <a:off x="3632191" y="3555991"/>
+            <a:ext cx="2146295" cy="215899"/>
+          </a:xfrm>
+          <a:prstGeom prst="rect">
+            <a:avLst/>
+          </a:prstGeom>
+          <a:noFill/>
+          <a:ln/>
+        </p:spPr>
+        <p:txBody>
+          <a:bodyPr wrap="square" lIns="0" tIns="0" rIns="0" bIns="0" rtlCol="0" anchor="ctr"/>
+          <a:lstStyle/>
+          <a:p>
+            <a:pPr indent="0" marL="0">
+              <a:buNone/>
+            </a:pPr>
+            <a:r>
+              <a:rPr lang="en-US" sz="900" b="1" spc="120" kern="0" dirty="0">
+                <a:solidFill>
+                  <a:srgbClr val="38B6FF"/>
+                </a:solidFill>
+                <a:latin typeface="Arial" pitchFamily="34" charset="0"/>
+                <a:ea typeface="Arial" pitchFamily="34" charset="-122"/>
+                <a:cs typeface="Arial" pitchFamily="34" charset="-120"/>
+              </a:rPr>
+              <a:t>INTRODUCTIES VERSTUURD</a:t>
+            </a:r>
+            <a:endParaRPr lang="en-US" sz="900" dirty="0"/>
+          </a:p>
+        </p:txBody>
+      </p:sp>
+      <p:sp>
+        <p:nvSpPr>
+          <p:cNvPr id="14" name="Text 12"/>
+          <p:cNvSpPr txBox="1"/>
+          <p:nvPr/>
+        </p:nvSpPr>
+        <p:spPr>
+          <a:xfrm>
+            <a:off x="3632191" y="3975090"/>
+            <a:ext cx="2146295" cy="888998"/>
+          </a:xfrm>
+          <a:prstGeom prst="rect">
+            <a:avLst/>
+          </a:prstGeom>
+          <a:noFill/>
+          <a:ln/>
+        </p:spPr>
+        <p:txBody>
+          <a:bodyPr wrap="square" lIns="0" tIns="0" rIns="0" bIns="0" rtlCol="0" anchor="t"/>
+          <a:lstStyle/>
+          <a:p>
+            <a:pPr indent="0" marL="0">
+              <a:lnSpc>
+                <a:spcPct val="135000"/>
+              </a:lnSpc>
+              <a:buNone/>
+            </a:pPr>
+            <a:r>
+              <a:rPr lang="en-US" sz="950" dirty="0">
+                <a:solidFill>
+                  <a:srgbClr val="6F6A5C"/>
+                </a:solidFill>
+                <a:latin typeface="Arial" pitchFamily="34" charset="0"/>
+                <a:ea typeface="Arial" pitchFamily="34" charset="-122"/>
+                <a:cs typeface="Arial" pitchFamily="34" charset="-120"/>
+              </a:rPr>
+              <a:t>Bedrijven die om informatie vroegen en binnen drie werkdagen worden nagebeld.</a:t>
+            </a:r>
+            <a:endParaRPr lang="en-US" sz="950" dirty="0"/>
+          </a:p>
+        </p:txBody>
+      </p:sp>
+      <p:sp>
+        <p:nvSpPr>
+          <p:cNvPr id="15" name="Shape 13"/>
+          <p:cNvSpPr/>
+          <p:nvPr/>
+        </p:nvSpPr>
+        <p:spPr>
+          <a:xfrm>
+            <a:off x="6172185" y="2730493"/>
+            <a:ext cx="2628893" cy="2222494"/>
+          </a:xfrm>
+          <a:prstGeom prst="roundRect">
+            <a:avLst>
+              <a:gd name="adj" fmla="val 4571"/>
+            </a:avLst>
+          </a:prstGeom>
+          <a:solidFill>
+            <a:srgbClr val="F8F4EB"/>
+          </a:solidFill>
+          <a:ln/>
+        </p:spPr>
+      </p:sp>
+      <p:sp>
+        <p:nvSpPr>
+          <p:cNvPr id="16" name="Text 14"/>
+          <p:cNvSpPr txBox="1"/>
+          <p:nvPr/>
+        </p:nvSpPr>
+        <p:spPr>
+          <a:xfrm>
+            <a:off x="6413484" y="2997193"/>
+            <a:ext cx="2146295" cy="507999"/>
+          </a:xfrm>
+          <a:prstGeom prst="rect">
+            <a:avLst/>
+          </a:prstGeom>
+          <a:noFill/>
+          <a:ln/>
+        </p:spPr>
+        <p:txBody>
+          <a:bodyPr wrap="square" lIns="0" tIns="0" rIns="0" bIns="0" rtlCol="0" anchor="ctr"/>
+          <a:lstStyle/>
+          <a:p>
+            <a:pPr indent="0" marL="0">
+              <a:buNone/>
+            </a:pPr>
+            <a:r>
+              <a:rPr lang="en-US" sz="3600" b="1" dirty="0">
+                <a:solidFill>
+                  <a:srgbClr val="1C2230"/>
+                </a:solidFill>
+                <a:latin typeface="Arial" pitchFamily="34" charset="0"/>
+                <a:ea typeface="Arial" pitchFamily="34" charset="-122"/>
+                <a:cs typeface="Arial" pitchFamily="34" charset="-120"/>
+              </a:rPr>
+              <a:t>39</a:t>
+            </a:r>
+            <a:endParaRPr lang="en-US" sz="3600" dirty="0"/>
+          </a:p>
+        </p:txBody>
+      </p:sp>
+      <p:sp>
+        <p:nvSpPr>
+          <p:cNvPr id="17" name="Text 15"/>
+          <p:cNvSpPr txBox="1"/>
+          <p:nvPr/>
+        </p:nvSpPr>
+        <p:spPr>
+          <a:xfrm>
+            <a:off x="6413484" y="3555991"/>
+            <a:ext cx="2146295" cy="215899"/>
+          </a:xfrm>
+          <a:prstGeom prst="rect">
+            <a:avLst/>
+          </a:prstGeom>
+          <a:noFill/>
+          <a:ln/>
+        </p:spPr>
+        <p:txBody>
+          <a:bodyPr wrap="square" lIns="0" tIns="0" rIns="0" bIns="0" rtlCol="0" anchor="ctr"/>
+          <a:lstStyle/>
+          <a:p>
+            <a:pPr indent="0" marL="0">
+              <a:buNone/>
+            </a:pPr>
+            <a:r>
+              <a:rPr lang="en-US" sz="900" b="1" spc="120" kern="0" dirty="0">
+                <a:solidFill>
+                  <a:srgbClr val="38B6FF"/>
+                </a:solidFill>
+                <a:latin typeface="Arial" pitchFamily="34" charset="0"/>
+                <a:ea typeface="Arial" pitchFamily="34" charset="-122"/>
+                <a:cs typeface="Arial" pitchFamily="34" charset="-120"/>
+              </a:rPr>
+              <a:t>STAAN NOG DEZE MAAND</a:t>
+            </a:r>
+            <a:endParaRPr lang="en-US" sz="900" dirty="0"/>
+          </a:p>
+        </p:txBody>
+      </p:sp>
+      <p:sp>
+        <p:nvSpPr>
+          <p:cNvPr id="18" name="Text 16"/>
+          <p:cNvSpPr txBox="1"/>
+          <p:nvPr/>
+        </p:nvSpPr>
+        <p:spPr>
+          <a:xfrm>
+            <a:off x="6413484" y="3975090"/>
+            <a:ext cx="2146295" cy="888998"/>
+          </a:xfrm>
+          <a:prstGeom prst="rect">
+            <a:avLst/>
+          </a:prstGeom>
+          <a:noFill/>
+          <a:ln/>
+        </p:spPr>
+        <p:txBody>
+          <a:bodyPr wrap="square" lIns="0" tIns="0" rIns="0" bIns="0" rtlCol="0" anchor="t"/>
+          <a:lstStyle/>
+          <a:p>
+            <a:pPr indent="0" marL="0">
+              <a:lnSpc>
+                <a:spcPct val="135000"/>
+              </a:lnSpc>
+              <a:buNone/>
+            </a:pPr>
+            <a:r>
+              <a:rPr lang="en-US" sz="950" dirty="0">
+                <a:solidFill>
+                  <a:srgbClr val="6F6A5C"/>
+                </a:solidFill>
+                <a:latin typeface="Arial" pitchFamily="34" charset="0"/>
+                <a:ea typeface="Arial" pitchFamily="34" charset="-122"/>
+                <a:cs typeface="Arial" pitchFamily="34" charset="-120"/>
+              </a:rPr>
+              <a:t>Concrete momenten in oktober, allemaal met naam en reden vastgelegd.</a:t>
+            </a:r>
+            <a:endParaRPr lang="en-US" sz="950" dirty="0"/>
+          </a:p>
+        </p:txBody>
+      </p:sp>
+      <p:sp>
+        <p:nvSpPr>
+          <p:cNvPr id="19" name="Shape 17"/>
+          <p:cNvSpPr/>
+          <p:nvPr/>
+        </p:nvSpPr>
+        <p:spPr>
+          <a:xfrm>
+            <a:off x="8953478" y="2730493"/>
+            <a:ext cx="2628893" cy="2222494"/>
+          </a:xfrm>
+          <a:prstGeom prst="roundRect">
+            <a:avLst>
+              <a:gd name="adj" fmla="val 4571"/>
+            </a:avLst>
+          </a:prstGeom>
+          <a:solidFill>
+            <a:srgbClr val="000000"/>
+          </a:solidFill>
+          <a:ln/>
+        </p:spPr>
+      </p:sp>
+      <p:sp>
+        <p:nvSpPr>
+          <p:cNvPr id="20" name="Text 18"/>
+          <p:cNvSpPr txBox="1"/>
+          <p:nvPr/>
+        </p:nvSpPr>
+        <p:spPr>
+          <a:xfrm>
+            <a:off x="9194777" y="2997193"/>
+            <a:ext cx="2146295" cy="507999"/>
+          </a:xfrm>
+          <a:prstGeom prst="rect">
+            <a:avLst/>
+          </a:prstGeom>
+          <a:noFill/>
+          <a:ln/>
+        </p:spPr>
+        <p:txBody>
+          <a:bodyPr wrap="square" lIns="0" tIns="0" rIns="0" bIns="0" rtlCol="0" anchor="ctr"/>
+          <a:lstStyle/>
+          <a:p>
+            <a:pPr indent="0" marL="0">
+              <a:buNone/>
+            </a:pPr>
+            <a:r>
+              <a:rPr lang="en-US" sz="3600" b="1" dirty="0">
+                <a:solidFill>
+                  <a:srgbClr val="38B6FF"/>
+                </a:solidFill>
+                <a:latin typeface="Arial" pitchFamily="34" charset="0"/>
+                <a:ea typeface="Arial" pitchFamily="34" charset="-122"/>
+                <a:cs typeface="Arial" pitchFamily="34" charset="-120"/>
+              </a:rPr>
+              <a:t>60</a:t>
+            </a:r>
+            <a:endParaRPr lang="en-US" sz="3600" dirty="0"/>
+          </a:p>
+        </p:txBody>
+      </p:sp>
+      <p:sp>
+        <p:nvSpPr>
+          <p:cNvPr id="21" name="Text 19"/>
+          <p:cNvSpPr txBox="1"/>
+          <p:nvPr/>
+        </p:nvSpPr>
+        <p:spPr>
+          <a:xfrm>
+            <a:off x="9194777" y="3555991"/>
+            <a:ext cx="2146295" cy="215899"/>
+          </a:xfrm>
+          <a:prstGeom prst="rect">
+            <a:avLst/>
+          </a:prstGeom>
+          <a:noFill/>
+          <a:ln/>
+        </p:spPr>
+        <p:txBody>
+          <a:bodyPr wrap="square" lIns="0" tIns="0" rIns="0" bIns="0" rtlCol="0" anchor="ctr"/>
+          <a:lstStyle/>
+          <a:p>
+            <a:pPr indent="0" marL="0">
+              <a:buNone/>
+            </a:pPr>
+            <a:r>
+              <a:rPr lang="en-US" sz="900" b="1" spc="120" kern="0" dirty="0">
+                <a:solidFill>
+                  <a:srgbClr val="38B6FF"/>
+                </a:solidFill>
+                <a:latin typeface="Arial" pitchFamily="34" charset="0"/>
+                <a:ea typeface="Arial" pitchFamily="34" charset="-122"/>
+                <a:cs typeface="Arial" pitchFamily="34" charset="-120"/>
+              </a:rPr>
+              <a:t>MET EEN DATUM VANAF NU</a:t>
+            </a:r>
+            <a:endParaRPr lang="en-US" sz="900" dirty="0"/>
+          </a:p>
+        </p:txBody>
+      </p:sp>
+      <p:sp>
+        <p:nvSpPr>
+          <p:cNvPr id="22" name="Text 20"/>
+          <p:cNvSpPr txBox="1"/>
+          <p:nvPr/>
+        </p:nvSpPr>
+        <p:spPr>
+          <a:xfrm>
+            <a:off x="9194777" y="3975090"/>
+            <a:ext cx="2146295" cy="888998"/>
+          </a:xfrm>
+          <a:prstGeom prst="rect">
+            <a:avLst/>
+          </a:prstGeom>
+          <a:noFill/>
+          <a:ln/>
+        </p:spPr>
+        <p:txBody>
+          <a:bodyPr wrap="square" lIns="0" tIns="0" rIns="0" bIns="0" rtlCol="0" anchor="t"/>
+          <a:lstStyle/>
+          <a:p>
+            <a:pPr indent="0" marL="0">
+              <a:lnSpc>
+                <a:spcPct val="135000"/>
+              </a:lnSpc>
+              <a:buNone/>
+            </a:pPr>
+            <a:r>
+              <a:rPr lang="en-US" sz="950" dirty="0">
                 <a:solidFill>
                   <a:srgbClr val="C2C8D2"/>
                 </a:solidFill>
@@ -15732,691 +16033,15 @@
                 <a:ea typeface="Arial" pitchFamily="34" charset="-122"/>
                 <a:cs typeface="Arial" pitchFamily="34" charset="-120"/>
               </a:rPr>
-              <a:t>BELLIJST</a:t>
-            </a:r>
-            <a:endParaRPr lang="en-US" sz="800" dirty="0"/>
-          </a:p>
-        </p:txBody>
-      </p:sp>
-      <p:sp>
-        <p:nvSpPr>
-          <p:cNvPr id="9" name="Text 7"/>
-          <p:cNvSpPr txBox="1"/>
-          <p:nvPr/>
-        </p:nvSpPr>
-        <p:spPr>
-          <a:xfrm>
-            <a:off x="3886190" y="2666993"/>
-            <a:ext cx="2349494" cy="469899"/>
-          </a:xfrm>
-          <a:prstGeom prst="rect">
-            <a:avLst/>
-          </a:prstGeom>
-          <a:noFill/>
-          <a:ln/>
-        </p:spPr>
-        <p:txBody>
-          <a:bodyPr wrap="square" lIns="0" tIns="0" rIns="0" bIns="0" rtlCol="0" anchor="ctr"/>
-          <a:lstStyle/>
-          <a:p>
-            <a:pPr indent="0" marL="0">
-              <a:buNone/>
-            </a:pPr>
-            <a:r>
-              <a:rPr lang="en-US" sz="800" b="1" spc="160" kern="0" dirty="0">
-                <a:solidFill>
-                  <a:srgbClr val="C2C8D2"/>
-                </a:solidFill>
-                <a:latin typeface="Arial" pitchFamily="34" charset="0"/>
-                <a:ea typeface="Arial" pitchFamily="34" charset="-122"/>
-                <a:cs typeface="Arial" pitchFamily="34" charset="-120"/>
-              </a:rPr>
-              <a:t>CONTACTPOGINGEN</a:t>
-            </a:r>
-            <a:endParaRPr lang="en-US" sz="800" dirty="0"/>
-          </a:p>
-        </p:txBody>
-      </p:sp>
-      <p:sp>
-        <p:nvSpPr>
-          <p:cNvPr id="10" name="Text 8"/>
-          <p:cNvSpPr txBox="1"/>
-          <p:nvPr/>
-        </p:nvSpPr>
-        <p:spPr>
-          <a:xfrm>
-            <a:off x="6324584" y="2666993"/>
-            <a:ext cx="2349494" cy="469899"/>
-          </a:xfrm>
-          <a:prstGeom prst="rect">
-            <a:avLst/>
-          </a:prstGeom>
-          <a:noFill/>
-          <a:ln/>
-        </p:spPr>
-        <p:txBody>
-          <a:bodyPr wrap="square" lIns="0" tIns="0" rIns="0" bIns="0" rtlCol="0" anchor="ctr"/>
-          <a:lstStyle/>
-          <a:p>
-            <a:pPr indent="0" marL="0">
-              <a:buNone/>
-            </a:pPr>
-            <a:r>
-              <a:rPr lang="en-US" sz="800" b="1" spc="160" kern="0" dirty="0">
-                <a:solidFill>
-                  <a:srgbClr val="C2C8D2"/>
-                </a:solidFill>
-                <a:latin typeface="Arial" pitchFamily="34" charset="0"/>
-                <a:ea typeface="Arial" pitchFamily="34" charset="-122"/>
-                <a:cs typeface="Arial" pitchFamily="34" charset="-120"/>
-              </a:rPr>
-              <a:t>AFSPRAKEN</a:t>
-            </a:r>
-            <a:endParaRPr lang="en-US" sz="800" dirty="0"/>
-          </a:p>
-        </p:txBody>
-      </p:sp>
-      <p:sp>
-        <p:nvSpPr>
-          <p:cNvPr id="11" name="Text 9"/>
-          <p:cNvSpPr txBox="1"/>
-          <p:nvPr/>
-        </p:nvSpPr>
-        <p:spPr>
-          <a:xfrm>
-            <a:off x="8737578" y="2666993"/>
-            <a:ext cx="2539994" cy="469899"/>
-          </a:xfrm>
-          <a:prstGeom prst="rect">
-            <a:avLst/>
-          </a:prstGeom>
-          <a:noFill/>
-          <a:ln/>
-        </p:spPr>
-        <p:txBody>
-          <a:bodyPr wrap="square" lIns="0" tIns="0" rIns="0" bIns="0" rtlCol="0" anchor="ctr"/>
-          <a:lstStyle/>
-          <a:p>
-            <a:pPr indent="0" marL="0">
-              <a:buNone/>
-            </a:pPr>
-            <a:r>
-              <a:rPr lang="en-US" sz="800" b="1" spc="160" kern="0" dirty="0">
-                <a:solidFill>
-                  <a:srgbClr val="C2C8D2"/>
-                </a:solidFill>
-                <a:latin typeface="Arial" pitchFamily="34" charset="0"/>
-                <a:ea typeface="Arial" pitchFamily="34" charset="-122"/>
-                <a:cs typeface="Arial" pitchFamily="34" charset="-120"/>
-              </a:rPr>
-              <a:t>PER 1.000 POGINGEN</a:t>
-            </a:r>
-            <a:endParaRPr lang="en-US" sz="800" dirty="0"/>
-          </a:p>
-        </p:txBody>
-      </p:sp>
-      <p:sp>
-        <p:nvSpPr>
-          <p:cNvPr id="12" name="Shape 10"/>
-          <p:cNvSpPr/>
-          <p:nvPr/>
-        </p:nvSpPr>
-        <p:spPr>
-          <a:xfrm>
-            <a:off x="615948" y="3136892"/>
-            <a:ext cx="10960073" cy="628648"/>
-          </a:xfrm>
-          <a:prstGeom prst="rect">
-            <a:avLst/>
-          </a:prstGeom>
-          <a:solidFill>
-            <a:srgbClr val="38B6FF">
-              <a:alpha val="11000"/>
-            </a:srgbClr>
-          </a:solidFill>
-          <a:ln/>
-        </p:spPr>
-      </p:sp>
-      <p:sp>
-        <p:nvSpPr>
-          <p:cNvPr id="13" name="Shape 11"/>
-          <p:cNvSpPr/>
-          <p:nvPr/>
-        </p:nvSpPr>
-        <p:spPr>
-          <a:xfrm>
-            <a:off x="609598" y="3136892"/>
-            <a:ext cx="10972773" cy="0"/>
-          </a:xfrm>
-          <a:prstGeom prst="line">
-            <a:avLst/>
-          </a:prstGeom>
-          <a:noFill/>
-          <a:ln w="9525">
-            <a:solidFill>
-              <a:srgbClr val="3A4152"/>
-            </a:solidFill>
-            <a:prstDash val="solid"/>
-          </a:ln>
-        </p:spPr>
-      </p:sp>
-      <p:sp>
-        <p:nvSpPr>
-          <p:cNvPr id="14" name="Text 12"/>
-          <p:cNvSpPr txBox="1"/>
-          <p:nvPr/>
-        </p:nvSpPr>
-        <p:spPr>
-          <a:xfrm>
-            <a:off x="888998" y="3136892"/>
-            <a:ext cx="2920993" cy="628648"/>
-          </a:xfrm>
-          <a:prstGeom prst="rect">
-            <a:avLst/>
-          </a:prstGeom>
-          <a:noFill/>
-          <a:ln/>
-        </p:spPr>
-        <p:txBody>
-          <a:bodyPr wrap="square" lIns="0" tIns="0" rIns="0" bIns="0" rtlCol="0" anchor="ctr"/>
-          <a:lstStyle/>
-          <a:p>
-            <a:pPr indent="0" marL="0">
-              <a:buNone/>
-            </a:pPr>
-            <a:r>
-              <a:rPr lang="en-US" sz="1250" b="1" dirty="0">
-                <a:solidFill>
-                  <a:srgbClr val="F2EFE6"/>
-                </a:solidFill>
-                <a:latin typeface="Arial" pitchFamily="34" charset="0"/>
-                <a:ea typeface="Arial" pitchFamily="34" charset="-122"/>
-                <a:cs typeface="Arial" pitchFamily="34" charset="-120"/>
-              </a:rPr>
-              <a:t>Relaties en gewenste klanten</a:t>
-            </a:r>
-            <a:endParaRPr lang="en-US" sz="1250" dirty="0"/>
-          </a:p>
-        </p:txBody>
-      </p:sp>
-      <p:sp>
-        <p:nvSpPr>
-          <p:cNvPr id="15" name="Text 13"/>
-          <p:cNvSpPr txBox="1"/>
-          <p:nvPr/>
-        </p:nvSpPr>
-        <p:spPr>
-          <a:xfrm>
-            <a:off x="3886190" y="3136892"/>
-            <a:ext cx="2349494" cy="628648"/>
-          </a:xfrm>
-          <a:prstGeom prst="rect">
-            <a:avLst/>
-          </a:prstGeom>
-          <a:noFill/>
-          <a:ln/>
-        </p:spPr>
-        <p:txBody>
-          <a:bodyPr wrap="square" lIns="0" tIns="0" rIns="0" bIns="0" rtlCol="0" anchor="ctr"/>
-          <a:lstStyle/>
-          <a:p>
-            <a:pPr indent="0" marL="0">
-              <a:buNone/>
-            </a:pPr>
-            <a:r>
-              <a:rPr lang="en-US" sz="1250" b="1" dirty="0">
-                <a:solidFill>
-                  <a:srgbClr val="F2EFE6"/>
-                </a:solidFill>
-                <a:latin typeface="Arial" pitchFamily="34" charset="0"/>
-                <a:ea typeface="Arial" pitchFamily="34" charset="-122"/>
-                <a:cs typeface="Arial" pitchFamily="34" charset="-120"/>
-              </a:rPr>
-              <a:t>207</a:t>
-            </a:r>
-            <a:endParaRPr lang="en-US" sz="1250" dirty="0"/>
-          </a:p>
-        </p:txBody>
-      </p:sp>
-      <p:sp>
-        <p:nvSpPr>
-          <p:cNvPr id="16" name="Text 14"/>
-          <p:cNvSpPr txBox="1"/>
-          <p:nvPr/>
-        </p:nvSpPr>
-        <p:spPr>
-          <a:xfrm>
-            <a:off x="6324584" y="3136892"/>
-            <a:ext cx="2349494" cy="628648"/>
-          </a:xfrm>
-          <a:prstGeom prst="rect">
-            <a:avLst/>
-          </a:prstGeom>
-          <a:noFill/>
-          <a:ln/>
-        </p:spPr>
-        <p:txBody>
-          <a:bodyPr wrap="square" lIns="0" tIns="0" rIns="0" bIns="0" rtlCol="0" anchor="ctr"/>
-          <a:lstStyle/>
-          <a:p>
-            <a:pPr indent="0" marL="0">
-              <a:buNone/>
-            </a:pPr>
-            <a:r>
-              <a:rPr lang="en-US" sz="1250" b="1" dirty="0">
-                <a:solidFill>
-                  <a:srgbClr val="F2EFE6"/>
-                </a:solidFill>
-                <a:latin typeface="Arial" pitchFamily="34" charset="0"/>
-                <a:ea typeface="Arial" pitchFamily="34" charset="-122"/>
-                <a:cs typeface="Arial" pitchFamily="34" charset="-120"/>
-              </a:rPr>
-              <a:t>4</a:t>
-            </a:r>
-            <a:endParaRPr lang="en-US" sz="1250" dirty="0"/>
-          </a:p>
-        </p:txBody>
-      </p:sp>
-      <p:sp>
-        <p:nvSpPr>
-          <p:cNvPr id="17" name="Text 15"/>
-          <p:cNvSpPr txBox="1"/>
-          <p:nvPr/>
-        </p:nvSpPr>
-        <p:spPr>
-          <a:xfrm>
-            <a:off x="8737578" y="3136892"/>
-            <a:ext cx="2539994" cy="628648"/>
-          </a:xfrm>
-          <a:prstGeom prst="rect">
-            <a:avLst/>
-          </a:prstGeom>
-          <a:noFill/>
-          <a:ln/>
-        </p:spPr>
-        <p:txBody>
-          <a:bodyPr wrap="square" lIns="0" tIns="0" rIns="0" bIns="0" rtlCol="0" anchor="ctr"/>
-          <a:lstStyle/>
-          <a:p>
-            <a:pPr indent="0" marL="0">
-              <a:buNone/>
-            </a:pPr>
-            <a:r>
-              <a:rPr lang="en-US" sz="1250" b="1" dirty="0">
-                <a:solidFill>
-                  <a:srgbClr val="F2EFE6"/>
-                </a:solidFill>
-                <a:latin typeface="Arial" pitchFamily="34" charset="0"/>
-                <a:ea typeface="Arial" pitchFamily="34" charset="-122"/>
-                <a:cs typeface="Arial" pitchFamily="34" charset="-120"/>
-              </a:rPr>
-              <a:t>19</a:t>
-            </a:r>
-            <a:endParaRPr lang="en-US" sz="1250" dirty="0"/>
-          </a:p>
-        </p:txBody>
-      </p:sp>
-      <p:sp>
-        <p:nvSpPr>
-          <p:cNvPr id="18" name="Shape 16"/>
-          <p:cNvSpPr/>
-          <p:nvPr/>
-        </p:nvSpPr>
-        <p:spPr>
-          <a:xfrm>
-            <a:off x="609598" y="3765541"/>
-            <a:ext cx="10972773" cy="0"/>
-          </a:xfrm>
-          <a:prstGeom prst="line">
-            <a:avLst/>
-          </a:prstGeom>
-          <a:noFill/>
-          <a:ln w="9525">
-            <a:solidFill>
-              <a:srgbClr val="3A4152"/>
-            </a:solidFill>
-            <a:prstDash val="solid"/>
-          </a:ln>
-        </p:spPr>
-      </p:sp>
-      <p:sp>
-        <p:nvSpPr>
-          <p:cNvPr id="19" name="Text 17"/>
-          <p:cNvSpPr txBox="1"/>
-          <p:nvPr/>
-        </p:nvSpPr>
-        <p:spPr>
-          <a:xfrm>
-            <a:off x="888998" y="3765541"/>
-            <a:ext cx="2920993" cy="628648"/>
-          </a:xfrm>
-          <a:prstGeom prst="rect">
-            <a:avLst/>
-          </a:prstGeom>
-          <a:noFill/>
-          <a:ln/>
-        </p:spPr>
-        <p:txBody>
-          <a:bodyPr wrap="square" lIns="0" tIns="0" rIns="0" bIns="0" rtlCol="0" anchor="ctr"/>
-          <a:lstStyle/>
-          <a:p>
-            <a:pPr indent="0" marL="0">
-              <a:buNone/>
-            </a:pPr>
-            <a:r>
-              <a:rPr lang="en-US" sz="1250" b="1" dirty="0">
-                <a:solidFill>
-                  <a:srgbClr val="F2EFE6"/>
-                </a:solidFill>
-                <a:latin typeface="Arial" pitchFamily="34" charset="0"/>
-                <a:ea typeface="Arial" pitchFamily="34" charset="-122"/>
-                <a:cs typeface="Arial" pitchFamily="34" charset="-120"/>
-              </a:rPr>
-              <a:t>Zakelijke dienstverlening, koud</a:t>
-            </a:r>
-            <a:endParaRPr lang="en-US" sz="1250" dirty="0"/>
-          </a:p>
-        </p:txBody>
-      </p:sp>
-      <p:sp>
-        <p:nvSpPr>
-          <p:cNvPr id="20" name="Text 18"/>
-          <p:cNvSpPr txBox="1"/>
-          <p:nvPr/>
-        </p:nvSpPr>
-        <p:spPr>
-          <a:xfrm>
-            <a:off x="3886190" y="3765541"/>
-            <a:ext cx="2349494" cy="628648"/>
-          </a:xfrm>
-          <a:prstGeom prst="rect">
-            <a:avLst/>
-          </a:prstGeom>
-          <a:noFill/>
-          <a:ln/>
-        </p:spPr>
-        <p:txBody>
-          <a:bodyPr wrap="square" lIns="0" tIns="0" rIns="0" bIns="0" rtlCol="0" anchor="ctr"/>
-          <a:lstStyle/>
-          <a:p>
-            <a:pPr indent="0" marL="0">
-              <a:buNone/>
-            </a:pPr>
-            <a:r>
-              <a:rPr lang="en-US" sz="1250" b="1" dirty="0">
-                <a:solidFill>
-                  <a:srgbClr val="F2EFE6"/>
-                </a:solidFill>
-                <a:latin typeface="Arial" pitchFamily="34" charset="0"/>
-                <a:ea typeface="Arial" pitchFamily="34" charset="-122"/>
-                <a:cs typeface="Arial" pitchFamily="34" charset="-120"/>
-              </a:rPr>
-              <a:t>1.333</a:t>
-            </a:r>
-            <a:endParaRPr lang="en-US" sz="1250" dirty="0"/>
-          </a:p>
-        </p:txBody>
-      </p:sp>
-      <p:sp>
-        <p:nvSpPr>
-          <p:cNvPr id="21" name="Text 19"/>
-          <p:cNvSpPr txBox="1"/>
-          <p:nvPr/>
-        </p:nvSpPr>
-        <p:spPr>
-          <a:xfrm>
-            <a:off x="6324584" y="3765541"/>
-            <a:ext cx="2349494" cy="628648"/>
-          </a:xfrm>
-          <a:prstGeom prst="rect">
-            <a:avLst/>
-          </a:prstGeom>
-          <a:noFill/>
-          <a:ln/>
-        </p:spPr>
-        <p:txBody>
-          <a:bodyPr wrap="square" lIns="0" tIns="0" rIns="0" bIns="0" rtlCol="0" anchor="ctr"/>
-          <a:lstStyle/>
-          <a:p>
-            <a:pPr indent="0" marL="0">
-              <a:buNone/>
-            </a:pPr>
-            <a:r>
-              <a:rPr lang="en-US" sz="1250" b="1" dirty="0">
-                <a:solidFill>
-                  <a:srgbClr val="F2EFE6"/>
-                </a:solidFill>
-                <a:latin typeface="Arial" pitchFamily="34" charset="0"/>
-                <a:ea typeface="Arial" pitchFamily="34" charset="-122"/>
-                <a:cs typeface="Arial" pitchFamily="34" charset="-120"/>
-              </a:rPr>
-              <a:t>8</a:t>
-            </a:r>
-            <a:endParaRPr lang="en-US" sz="1250" dirty="0"/>
-          </a:p>
-        </p:txBody>
-      </p:sp>
-      <p:sp>
-        <p:nvSpPr>
-          <p:cNvPr id="22" name="Text 20"/>
-          <p:cNvSpPr txBox="1"/>
-          <p:nvPr/>
-        </p:nvSpPr>
-        <p:spPr>
-          <a:xfrm>
-            <a:off x="8737578" y="3765541"/>
-            <a:ext cx="2539994" cy="628648"/>
-          </a:xfrm>
-          <a:prstGeom prst="rect">
-            <a:avLst/>
-          </a:prstGeom>
-          <a:noFill/>
-          <a:ln/>
-        </p:spPr>
-        <p:txBody>
-          <a:bodyPr wrap="square" lIns="0" tIns="0" rIns="0" bIns="0" rtlCol="0" anchor="ctr"/>
-          <a:lstStyle/>
-          <a:p>
-            <a:pPr indent="0" marL="0">
-              <a:buNone/>
-            </a:pPr>
-            <a:r>
-              <a:rPr lang="en-US" sz="1250" b="1" dirty="0">
-                <a:solidFill>
-                  <a:srgbClr val="F2EFE6"/>
-                </a:solidFill>
-                <a:latin typeface="Arial" pitchFamily="34" charset="0"/>
-                <a:ea typeface="Arial" pitchFamily="34" charset="-122"/>
-                <a:cs typeface="Arial" pitchFamily="34" charset="-120"/>
-              </a:rPr>
-              <a:t>6</a:t>
-            </a:r>
-            <a:endParaRPr lang="en-US" sz="1250" dirty="0"/>
+              <a:t>Dit is werk dat al gedaan en betaald is. Het rendeert pas in werkperiode 4.</a:t>
+            </a:r>
+            <a:endParaRPr lang="en-US" sz="950" dirty="0"/>
           </a:p>
         </p:txBody>
       </p:sp>
       <p:sp>
         <p:nvSpPr>
           <p:cNvPr id="23" name="Shape 21"/>
-          <p:cNvSpPr/>
-          <p:nvPr/>
-        </p:nvSpPr>
-        <p:spPr>
-          <a:xfrm>
-            <a:off x="609598" y="4394189"/>
-            <a:ext cx="10972773" cy="0"/>
-          </a:xfrm>
-          <a:prstGeom prst="line">
-            <a:avLst/>
-          </a:prstGeom>
-          <a:noFill/>
-          <a:ln w="9525">
-            <a:solidFill>
-              <a:srgbClr val="3A4152"/>
-            </a:solidFill>
-            <a:prstDash val="solid"/>
-          </a:ln>
-        </p:spPr>
-      </p:sp>
-      <p:sp>
-        <p:nvSpPr>
-          <p:cNvPr id="24" name="Text 22"/>
-          <p:cNvSpPr txBox="1"/>
-          <p:nvPr/>
-        </p:nvSpPr>
-        <p:spPr>
-          <a:xfrm>
-            <a:off x="888998" y="4394189"/>
-            <a:ext cx="2920993" cy="628648"/>
-          </a:xfrm>
-          <a:prstGeom prst="rect">
-            <a:avLst/>
-          </a:prstGeom>
-          <a:noFill/>
-          <a:ln/>
-        </p:spPr>
-        <p:txBody>
-          <a:bodyPr wrap="square" lIns="0" tIns="0" rIns="0" bIns="0" rtlCol="0" anchor="ctr"/>
-          <a:lstStyle/>
-          <a:p>
-            <a:pPr indent="0" marL="0">
-              <a:buNone/>
-            </a:pPr>
-            <a:r>
-              <a:rPr lang="en-US" sz="1250" b="1" dirty="0">
-                <a:solidFill>
-                  <a:srgbClr val="F2EFE6"/>
-                </a:solidFill>
-                <a:latin typeface="Arial" pitchFamily="34" charset="0"/>
-                <a:ea typeface="Arial" pitchFamily="34" charset="-122"/>
-                <a:cs typeface="Arial" pitchFamily="34" charset="-120"/>
-              </a:rPr>
-              <a:t>Bouw en techniek, koud</a:t>
-            </a:r>
-            <a:endParaRPr lang="en-US" sz="1250" dirty="0"/>
-          </a:p>
-        </p:txBody>
-      </p:sp>
-      <p:sp>
-        <p:nvSpPr>
-          <p:cNvPr id="25" name="Text 23"/>
-          <p:cNvSpPr txBox="1"/>
-          <p:nvPr/>
-        </p:nvSpPr>
-        <p:spPr>
-          <a:xfrm>
-            <a:off x="3886190" y="4394189"/>
-            <a:ext cx="2349494" cy="628648"/>
-          </a:xfrm>
-          <a:prstGeom prst="rect">
-            <a:avLst/>
-          </a:prstGeom>
-          <a:noFill/>
-          <a:ln/>
-        </p:spPr>
-        <p:txBody>
-          <a:bodyPr wrap="square" lIns="0" tIns="0" rIns="0" bIns="0" rtlCol="0" anchor="ctr"/>
-          <a:lstStyle/>
-          <a:p>
-            <a:pPr indent="0" marL="0">
-              <a:buNone/>
-            </a:pPr>
-            <a:r>
-              <a:rPr lang="en-US" sz="1250" b="1" dirty="0">
-                <a:solidFill>
-                  <a:srgbClr val="F2EFE6"/>
-                </a:solidFill>
-                <a:latin typeface="Arial" pitchFamily="34" charset="0"/>
-                <a:ea typeface="Arial" pitchFamily="34" charset="-122"/>
-                <a:cs typeface="Arial" pitchFamily="34" charset="-120"/>
-              </a:rPr>
-              <a:t>99</a:t>
-            </a:r>
-            <a:endParaRPr lang="en-US" sz="1250" dirty="0"/>
-          </a:p>
-        </p:txBody>
-      </p:sp>
-      <p:sp>
-        <p:nvSpPr>
-          <p:cNvPr id="26" name="Text 24"/>
-          <p:cNvSpPr txBox="1"/>
-          <p:nvPr/>
-        </p:nvSpPr>
-        <p:spPr>
-          <a:xfrm>
-            <a:off x="6324584" y="4394189"/>
-            <a:ext cx="2349494" cy="628648"/>
-          </a:xfrm>
-          <a:prstGeom prst="rect">
-            <a:avLst/>
-          </a:prstGeom>
-          <a:noFill/>
-          <a:ln/>
-        </p:spPr>
-        <p:txBody>
-          <a:bodyPr wrap="square" lIns="0" tIns="0" rIns="0" bIns="0" rtlCol="0" anchor="ctr"/>
-          <a:lstStyle/>
-          <a:p>
-            <a:pPr indent="0" marL="0">
-              <a:buNone/>
-            </a:pPr>
-            <a:r>
-              <a:rPr lang="en-US" sz="1250" b="1" dirty="0">
-                <a:solidFill>
-                  <a:srgbClr val="F2EFE6"/>
-                </a:solidFill>
-                <a:latin typeface="Arial" pitchFamily="34" charset="0"/>
-                <a:ea typeface="Arial" pitchFamily="34" charset="-122"/>
-                <a:cs typeface="Arial" pitchFamily="34" charset="-120"/>
-              </a:rPr>
-              <a:t>0</a:t>
-            </a:r>
-            <a:endParaRPr lang="en-US" sz="1250" dirty="0"/>
-          </a:p>
-        </p:txBody>
-      </p:sp>
-      <p:sp>
-        <p:nvSpPr>
-          <p:cNvPr id="27" name="Text 25"/>
-          <p:cNvSpPr txBox="1"/>
-          <p:nvPr/>
-        </p:nvSpPr>
-        <p:spPr>
-          <a:xfrm>
-            <a:off x="8737578" y="4394189"/>
-            <a:ext cx="2539994" cy="628648"/>
-          </a:xfrm>
-          <a:prstGeom prst="rect">
-            <a:avLst/>
-          </a:prstGeom>
-          <a:noFill/>
-          <a:ln/>
-        </p:spPr>
-        <p:txBody>
-          <a:bodyPr wrap="square" lIns="0" tIns="0" rIns="0" bIns="0" rtlCol="0" anchor="ctr"/>
-          <a:lstStyle/>
-          <a:p>
-            <a:pPr indent="0" marL="0">
-              <a:buNone/>
-            </a:pPr>
-            <a:r>
-              <a:rPr lang="en-US" sz="1250" b="1" dirty="0">
-                <a:solidFill>
-                  <a:srgbClr val="F2EFE6"/>
-                </a:solidFill>
-                <a:latin typeface="Arial" pitchFamily="34" charset="0"/>
-                <a:ea typeface="Arial" pitchFamily="34" charset="-122"/>
-                <a:cs typeface="Arial" pitchFamily="34" charset="-120"/>
-              </a:rPr>
-              <a:t>0</a:t>
-            </a:r>
-            <a:endParaRPr lang="en-US" sz="1250" dirty="0"/>
-          </a:p>
-        </p:txBody>
-      </p:sp>
-      <p:sp>
-        <p:nvSpPr>
-          <p:cNvPr id="28" name="Shape 26"/>
           <p:cNvSpPr/>
           <p:nvPr/>
         </p:nvSpPr>
@@ -16436,14 +16061,14 @@
       </p:sp>
       <p:sp>
         <p:nvSpPr>
-          <p:cNvPr id="29" name="Text 27"/>
-          <p:cNvSpPr txBox="1"/>
-          <p:nvPr/>
-        </p:nvSpPr>
-        <p:spPr>
-          <a:xfrm>
-            <a:off x="800098" y="5651486"/>
-            <a:ext cx="9905975" cy="482599"/>
+          <p:cNvPr id="24" name="Text 22"/>
+          <p:cNvSpPr txBox="1"/>
+          <p:nvPr/>
+        </p:nvSpPr>
+        <p:spPr>
+          <a:xfrm>
+            <a:off x="800098" y="5714986"/>
+            <a:ext cx="9905975" cy="355599"/>
           </a:xfrm>
           <a:prstGeom prst="rect">
             <a:avLst/>
@@ -16461,13 +16086,13 @@
             <a:r>
               <a:rPr lang="en-US" sz="1200" b="1" dirty="0">
                 <a:solidFill>
-                  <a:srgbClr val="F2EFE6"/>
-                </a:solidFill>
-                <a:latin typeface="Arial" pitchFamily="34" charset="0"/>
-                <a:ea typeface="Arial" pitchFamily="34" charset="-122"/>
-                <a:cs typeface="Arial" pitchFamily="34" charset="-120"/>
-              </a:rPr>
-              <a:t>Op de lijst met jullie relaties en gewenste klanten ligt het rendement ruim drie keer hoger. Het gaat om vier afspraken uit 207 pogingen, dus het is een richting en geen zekerheid. Wel is het de knop waarmee we van 1,1 naar 1,5 afspraak per beldag komen: ongeveer een derde van de lijst uit jullie eigen relaties.</a:t>
+                  <a:srgbClr val="1C2230"/>
+                </a:solidFill>
+                <a:latin typeface="Arial" pitchFamily="34" charset="0"/>
+                <a:ea typeface="Arial" pitchFamily="34" charset="-122"/>
+                <a:cs typeface="Arial" pitchFamily="34" charset="-120"/>
+              </a:rPr>
+              <a:t>De eerste gesprekken zijn het zwaarst in deze markt. Deze zestig zijn al langs de receptie, kennen de naam oké en weten waarom er gebeld wordt.</a:t>
             </a:r>
             <a:endParaRPr lang="en-US" sz="1200" dirty="0"/>
           </a:p>
@@ -17313,7 +16938,7 @@
                 <a:ea typeface="Arial" pitchFamily="34" charset="-122"/>
                 <a:cs typeface="Arial" pitchFamily="34" charset="-120"/>
               </a:rPr>
-              <a:t>Waar we op mikken vanaf werkperiode 4. In de pilot stond het op 1,1 per beldag, de lijst met jullie eigen relaties op bijna 3.</a:t>
+              <a:t>Het target vanaf werkperiode 4. Vier beldagen zijn dan zes afspraken per werkperiode.</a:t>
             </a:r>
             <a:endParaRPr lang="en-US" sz="950" dirty="0"/>
           </a:p>
@@ -17372,7 +16997,7 @@
                 <a:ea typeface="Arial" pitchFamily="34" charset="-122"/>
                 <a:cs typeface="Arial" pitchFamily="34" charset="-120"/>
               </a:rPr>
-              <a:t>Wij rekenen in beldagen en niet in uren, omdat een uur niets zegt over wat eruit komt. Vier beldagen met dit target zijn zes afspraken per werkperiode, precies het aantal uit de overeenkomst.</a:t>
+              <a:t>Wij rekenen in beldagen en niet in uren, omdat een uur niets zegt over wat eruit komt. Vier beldagen zijn zes afspraken per werkperiode, precies het aantal uit de overeenkomst.</a:t>
             </a:r>
             <a:endParaRPr lang="en-US" sz="1200" dirty="0"/>
           </a:p>

</xml_diff>

<commit_message>
OK Creative: werkperiode 3 op target, totaal naar veertien
Twaalf afspraken staan er nu, twee volgen nog voor 25 oktober. Daarmee komt
werkperiode 3 op de afgesproken zes en het totaal op veertien. De vergelijking
draait nu om de zekerheid: zes vastgelegd met een gratis beldag als vangnet,
tegenover geen garantie nu.

Co-Authored-By: Claude Opus 5 <noreply@anthropic.com>
Claude-Session: https://claude.ai/code/session_0141FN3f3hHkYQHTyvTJJGrw
</commit_message>
<xml_diff>
--- a/output/LINK. voorstel OK Creative Agency.pptx
+++ b/output/LINK. voorstel OK Creative Agency.pptx
@@ -4780,7 +4780,7 @@
                 <a:ea typeface="Arial" pitchFamily="34" charset="-122"/>
                 <a:cs typeface="Arial" pitchFamily="34" charset="-120"/>
               </a:rPr>
-              <a:t>Zes afspraken per maand met </a:t>
+              <a:t>Zes afspraken per maand, nu </a:t>
             </a:r>
             <a:pPr algn="l" indent="0" marL="0">
               <a:lnSpc>
@@ -4797,7 +4797,7 @@
                 <a:ea typeface="Georgia" pitchFamily="34" charset="-122"/>
                 <a:cs typeface="Georgia" pitchFamily="34" charset="-120"/>
               </a:rPr>
-              <a:t>vier beldagen</a:t>
+              <a:t>vastgelegd</a:t>
             </a:r>
             <a:pPr algn="l" indent="0" marL="0">
               <a:lnSpc>
@@ -5096,7 +5096,7 @@
                 <a:ea typeface="Arial" pitchFamily="34" charset="-122"/>
                 <a:cs typeface="Arial" pitchFamily="34" charset="-120"/>
               </a:rPr>
-              <a:t>± 556</a:t>
+              <a:t>± 553</a:t>
             </a:r>
             <a:endParaRPr lang="en-US" sz="1150" dirty="0"/>
           </a:p>
@@ -5197,7 +5197,7 @@
                 <a:ea typeface="Arial" pitchFamily="34" charset="-122"/>
                 <a:cs typeface="Arial" pitchFamily="34" charset="-120"/>
               </a:rPr>
-              <a:t>± 4</a:t>
+              <a:t>± 5</a:t>
             </a:r>
             <a:endParaRPr lang="en-US" sz="1150" dirty="0"/>
           </a:p>
@@ -5259,7 +5259,7 @@
                 <a:ea typeface="Arial" pitchFamily="34" charset="-122"/>
                 <a:cs typeface="Arial" pitchFamily="34" charset="-120"/>
               </a:rPr>
-              <a:t>Per beldag</a:t>
+              <a:t>Garantie</a:t>
             </a:r>
             <a:endParaRPr lang="en-US" sz="950" dirty="0"/>
           </a:p>
@@ -5298,7 +5298,7 @@
                 <a:ea typeface="Arial" pitchFamily="34" charset="-122"/>
                 <a:cs typeface="Arial" pitchFamily="34" charset="-120"/>
               </a:rPr>
-              <a:t>± € 540</a:t>
+              <a:t>geen</a:t>
             </a:r>
             <a:endParaRPr lang="en-US" sz="1150" dirty="0"/>
           </a:p>
@@ -5844,7 +5844,7 @@
                 <a:ea typeface="Arial" pitchFamily="34" charset="-122"/>
                 <a:cs typeface="Arial" pitchFamily="34" charset="-120"/>
               </a:rPr>
-              <a:t>Per beldag</a:t>
+              <a:t>Garantie</a:t>
             </a:r>
             <a:endParaRPr lang="en-US" sz="950" dirty="0"/>
           </a:p>
@@ -5883,7 +5883,7 @@
                 <a:ea typeface="Arial" pitchFamily="34" charset="-122"/>
                 <a:cs typeface="Arial" pitchFamily="34" charset="-120"/>
               </a:rPr>
-              <a:t>€ 600</a:t>
+              <a:t>gratis beldag</a:t>
             </a:r>
             <a:endParaRPr lang="en-US" sz="1150" dirty="0"/>
           </a:p>
@@ -6429,7 +6429,7 @@
                 <a:ea typeface="Arial" pitchFamily="34" charset="-122"/>
                 <a:cs typeface="Arial" pitchFamily="34" charset="-120"/>
               </a:rPr>
-              <a:t>Per beldag</a:t>
+              <a:t>Garantie</a:t>
             </a:r>
             <a:endParaRPr lang="en-US" sz="950" dirty="0"/>
           </a:p>
@@ -6468,7 +6468,7 @@
                 <a:ea typeface="Arial" pitchFamily="34" charset="-122"/>
                 <a:cs typeface="Arial" pitchFamily="34" charset="-120"/>
               </a:rPr>
-              <a:t>€ 575</a:t>
+              <a:t>gratis beldag</a:t>
             </a:r>
             <a:endParaRPr lang="en-US" sz="1150" dirty="0"/>
           </a:p>
@@ -6628,7 +6628,7 @@
                 <a:ea typeface="Arial" pitchFamily="34" charset="-122"/>
                 <a:cs typeface="Arial" pitchFamily="34" charset="-120"/>
               </a:rPr>
-              <a:t>Je betaalt nu al ongeveer € 540 per beldag. Met vier beldagen en een derde eigen relaties op de lijst komen we op de zes afspraken per maand die in de overeenkomst staan. Wil je sneller, dan zijn het er negen bij zes beldagen.</a:t>
+              <a:t>Het verschil is niet alleen het aantal, maar de zekerheid eronder. Zes afspraken per werkperiode wordt een afspraak in plaats van een verwachting, en halen we het niet, dan bellen we een dag extra op onze kosten.</a:t>
             </a:r>
             <a:endParaRPr lang="en-US" sz="1200" dirty="0"/>
           </a:p>
@@ -14161,7 +14161,7 @@
                 <a:ea typeface="Arial" pitchFamily="34" charset="-122"/>
                 <a:cs typeface="Arial" pitchFamily="34" charset="-120"/>
               </a:rPr>
-              <a:t>12</a:t>
+              <a:t>14</a:t>
             </a:r>
             <a:endParaRPr lang="en-US" sz="3600" dirty="0"/>
           </a:p>
@@ -14242,7 +14242,7 @@
                 <a:ea typeface="Arial" pitchFamily="34" charset="-122"/>
                 <a:cs typeface="Arial" pitchFamily="34" charset="-120"/>
               </a:rPr>
-              <a:t>Zeven ingeplande afspraken voor Frits en vijf leads rechtstreeks overgedragen.</a:t>
+              <a:t>Twaalf staan er nu, twee volgen nog voor 25 oktober. Daarmee komt werkperiode 3 op het afgesproken aantal van zes.</a:t>
             </a:r>
             <a:endParaRPr lang="en-US" sz="950" dirty="0"/>
           </a:p>
@@ -14301,7 +14301,7 @@
                 <a:ea typeface="Arial" pitchFamily="34" charset="-122"/>
                 <a:cs typeface="Arial" pitchFamily="34" charset="-120"/>
               </a:rPr>
-              <a:t>Deze cijfers komen uit de belexport van 11 oktober. Werkperiode 3 loopt nog door tot 25 oktober, dus hier komt nog bij.</a:t>
+              <a:t>Deze cijfers komen uit de belexport van 11 oktober. Werkperiode 3 loopt nog door tot 25 oktober.</a:t>
             </a:r>
             <a:endParaRPr lang="en-US" sz="1200" dirty="0"/>
           </a:p>
@@ -14545,7 +14545,7 @@
                 <a:ea typeface="Arial" pitchFamily="34" charset="-122"/>
                 <a:cs typeface="Arial" pitchFamily="34" charset="-120"/>
               </a:rPr>
-              <a:t>Twaalf bedrijven, waaronder deze </a:t>
+              <a:t>De bedrijven die aan tafel kwamen, waaronder deze </a:t>
             </a:r>
             <a:pPr algn="l" indent="0" marL="0">
               <a:lnSpc>

</xml_diff>

<commit_message>
OK Creative: overal de volledige naam in plaats van de korte
Co-Authored-By: Claude Opus 5 <noreply@anthropic.com>
Claude-Session: https://claude.ai/code/session_0141FN3f3hHkYQHTyvTJJGrw
</commit_message>
<xml_diff>
--- a/output/LINK. voorstel OK Creative Agency.pptx
+++ b/output/LINK. voorstel OK Creative Agency.pptx
@@ -11985,7 +11985,7 @@
                 <a:ea typeface="Arial" pitchFamily="34" charset="-122"/>
                 <a:cs typeface="Arial" pitchFamily="34" charset="-120"/>
               </a:rPr>
-              <a:t>We bellen namens oké, met de insteek van Frits: hij heeft punten voorbereid over hoe het bedrijf naar buiten communiceert en wil die toelichten.</a:t>
+              <a:t>We bellen namens OK Creative Agency, met de insteek van Frits: hij heeft punten voorbereid over hoe het bedrijf naar buiten communiceert en wil die toelichten.</a:t>
             </a:r>
             <a:endParaRPr lang="en-US" sz="900" dirty="0"/>
           </a:p>
@@ -13958,7 +13958,7 @@
                 <a:ea typeface="Arial" pitchFamily="34" charset="-122"/>
                 <a:cs typeface="Arial" pitchFamily="34" charset="-120"/>
               </a:rPr>
-              <a:t>Allemaal benaderd namens oké. Voor een naam die vorig jaar nog Onze Kapel heette is dat op zichzelf waarde.</a:t>
+              <a:t>Allemaal benaderd namens OK Creative Agency. Voor een naam die vorig jaar nog Onze Kapel heette is dat op zichzelf waarde.</a:t>
             </a:r>
             <a:endParaRPr lang="en-US" sz="950" dirty="0"/>
           </a:p>
@@ -14731,7 +14731,7 @@
                 <a:ea typeface="Arial" pitchFamily="34" charset="-122"/>
                 <a:cs typeface="Arial" pitchFamily="34" charset="-120"/>
               </a:rPr>
-              <a:t>Reageerde op de mail vanuit oké. Ellen wil online sparren. Gekomen uit jullie eigen lijst met gewenste klanten.</a:t>
+              <a:t>Reageerde op de mail vanuit OK Creative Agency. Ellen wil online sparren. Gekomen uit jullie eigen lijst met gewenste klanten.</a:t>
             </a:r>
             <a:endParaRPr lang="en-US" sz="950" dirty="0"/>
           </a:p>
@@ -16092,7 +16092,7 @@
                 <a:ea typeface="Arial" pitchFamily="34" charset="-122"/>
                 <a:cs typeface="Arial" pitchFamily="34" charset="-120"/>
               </a:rPr>
-              <a:t>De eerste gesprekken zijn het zwaarst in deze markt. Deze zestig zijn al langs de receptie, kennen de naam oké en weten waarom er gebeld wordt.</a:t>
+              <a:t>De eerste gesprekken zijn het zwaarst in deze markt. Deze zestig zijn al langs de receptie, kennen de naam OK Creative Agency en weten waarom er gebeld wordt.</a:t>
             </a:r>
             <a:endParaRPr lang="en-US" sz="1200" dirty="0"/>
           </a:p>

</xml_diff>